<commit_message>
chore(slides): update formatting for 5 onwards slides
</commit_message>
<xml_diff>
--- a/slides/flsg/7-finetuning-flsg.pptx
+++ b/slides/flsg/7-finetuning-flsg.pptx
@@ -1343,7 +1343,7 @@
           <a:p>
             <a:fld id="{9F0382AD-F4DE-5244-99F0-D1973462CD0B}" type="datetimeFigureOut">
               <a:rPr lang="en-US" smtClean="0"/>
-              <a:t>5/11/26</a:t>
+              <a:t>5/15/26</a:t>
             </a:fld>
             <a:endParaRPr lang="en-US"/>
           </a:p>
@@ -2409,7 +2409,7 @@
           <a:p>
             <a:fld id="{846CE7D5-CF57-46EF-B807-FDD0502418D4}" type="datetimeFigureOut">
               <a:rPr lang="en-GB" smtClean="0"/>
-              <a:t>11/05/2026</a:t>
+              <a:t>15/05/2026</a:t>
             </a:fld>
             <a:endParaRPr lang="en-GB"/>
           </a:p>
@@ -2579,7 +2579,7 @@
           <a:p>
             <a:fld id="{846CE7D5-CF57-46EF-B807-FDD0502418D4}" type="datetimeFigureOut">
               <a:rPr lang="en-GB" smtClean="0"/>
-              <a:t>11/05/2026</a:t>
+              <a:t>15/05/2026</a:t>
             </a:fld>
             <a:endParaRPr lang="en-GB"/>
           </a:p>
@@ -2759,7 +2759,7 @@
           <a:p>
             <a:fld id="{846CE7D5-CF57-46EF-B807-FDD0502418D4}" type="datetimeFigureOut">
               <a:rPr lang="en-GB" smtClean="0"/>
-              <a:t>11/05/2026</a:t>
+              <a:t>15/05/2026</a:t>
             </a:fld>
             <a:endParaRPr lang="en-GB"/>
           </a:p>
@@ -2929,7 +2929,7 @@
           <a:p>
             <a:fld id="{846CE7D5-CF57-46EF-B807-FDD0502418D4}" type="datetimeFigureOut">
               <a:rPr lang="en-GB" smtClean="0"/>
-              <a:t>11/05/2026</a:t>
+              <a:t>15/05/2026</a:t>
             </a:fld>
             <a:endParaRPr lang="en-GB"/>
           </a:p>
@@ -3175,7 +3175,7 @@
           <a:p>
             <a:fld id="{846CE7D5-CF57-46EF-B807-FDD0502418D4}" type="datetimeFigureOut">
               <a:rPr lang="en-GB" smtClean="0"/>
-              <a:t>11/05/2026</a:t>
+              <a:t>15/05/2026</a:t>
             </a:fld>
             <a:endParaRPr lang="en-GB"/>
           </a:p>
@@ -3407,7 +3407,7 @@
           <a:p>
             <a:fld id="{846CE7D5-CF57-46EF-B807-FDD0502418D4}" type="datetimeFigureOut">
               <a:rPr lang="en-GB" smtClean="0"/>
-              <a:t>11/05/2026</a:t>
+              <a:t>15/05/2026</a:t>
             </a:fld>
             <a:endParaRPr lang="en-GB"/>
           </a:p>
@@ -3774,7 +3774,7 @@
           <a:p>
             <a:fld id="{846CE7D5-CF57-46EF-B807-FDD0502418D4}" type="datetimeFigureOut">
               <a:rPr lang="en-GB" smtClean="0"/>
-              <a:t>11/05/2026</a:t>
+              <a:t>15/05/2026</a:t>
             </a:fld>
             <a:endParaRPr lang="en-GB"/>
           </a:p>
@@ -3892,7 +3892,7 @@
           <a:p>
             <a:fld id="{846CE7D5-CF57-46EF-B807-FDD0502418D4}" type="datetimeFigureOut">
               <a:rPr lang="en-GB" smtClean="0"/>
-              <a:t>11/05/2026</a:t>
+              <a:t>15/05/2026</a:t>
             </a:fld>
             <a:endParaRPr lang="en-GB"/>
           </a:p>
@@ -3987,7 +3987,7 @@
           <a:p>
             <a:fld id="{846CE7D5-CF57-46EF-B807-FDD0502418D4}" type="datetimeFigureOut">
               <a:rPr lang="en-GB" smtClean="0"/>
-              <a:t>11/05/2026</a:t>
+              <a:t>15/05/2026</a:t>
             </a:fld>
             <a:endParaRPr lang="en-GB"/>
           </a:p>
@@ -4264,7 +4264,7 @@
           <a:p>
             <a:fld id="{846CE7D5-CF57-46EF-B807-FDD0502418D4}" type="datetimeFigureOut">
               <a:rPr lang="en-GB" smtClean="0"/>
-              <a:t>11/05/2026</a:t>
+              <a:t>15/05/2026</a:t>
             </a:fld>
             <a:endParaRPr lang="en-GB"/>
           </a:p>
@@ -4521,7 +4521,7 @@
           <a:p>
             <a:fld id="{846CE7D5-CF57-46EF-B807-FDD0502418D4}" type="datetimeFigureOut">
               <a:rPr lang="en-GB" smtClean="0"/>
-              <a:t>11/05/2026</a:t>
+              <a:t>15/05/2026</a:t>
             </a:fld>
             <a:endParaRPr lang="en-GB"/>
           </a:p>
@@ -4586,9 +4586,18 @@
 <p:sldMaster xmlns:a="http://schemas.openxmlformats.org/drawingml/2006/main" xmlns:r="http://schemas.openxmlformats.org/officeDocument/2006/relationships" xmlns:p="http://schemas.openxmlformats.org/presentationml/2006/main">
   <p:cSld>
     <p:bg>
-      <p:bgRef idx="1001">
-        <a:schemeClr val="bg1"/>
-      </p:bgRef>
+      <p:bgPr>
+        <a:blipFill dpi="0" rotWithShape="1">
+          <a:blip r:embed="rId13">
+            <a:lum/>
+          </a:blip>
+          <a:srcRect/>
+          <a:stretch>
+            <a:fillRect/>
+          </a:stretch>
+        </a:blipFill>
+        <a:effectLst/>
+      </p:bgPr>
     </p:bg>
     <p:spTree>
       <p:nvGrpSpPr>
@@ -4734,7 +4743,7 @@
           <a:p>
             <a:fld id="{846CE7D5-CF57-46EF-B807-FDD0502418D4}" type="datetimeFigureOut">
               <a:rPr lang="en-GB" smtClean="0"/>
-              <a:t>11/05/2026</a:t>
+              <a:t>15/05/2026</a:t>
             </a:fld>
             <a:endParaRPr lang="en-GB"/>
           </a:p>
@@ -5168,7 +5177,7 @@
         </p:blipFill>
         <p:spPr bwMode="auto">
           <a:xfrm>
-            <a:off x="2720775" y="1608199"/>
+            <a:off x="2720775" y="1342335"/>
             <a:ext cx="6750449" cy="3797127"/>
           </a:xfrm>
           <a:prstGeom prst="rect">
@@ -5208,7 +5217,7 @@
         </p:blipFill>
         <p:spPr>
           <a:xfrm>
-            <a:off x="838200" y="5322837"/>
+            <a:off x="838199" y="4979211"/>
             <a:ext cx="7772400" cy="1170038"/>
           </a:xfrm>
           <a:prstGeom prst="rect">
@@ -5290,7 +5299,11 @@
           <a:lstStyle/>
           <a:p>
             <a:r>
-              <a:rPr lang="en-US" dirty="0"/>
+              <a:rPr lang="en-US" dirty="0">
+                <a:latin typeface="CMU Serif Roman" panose="02000603000000000000" pitchFamily="2" charset="0"/>
+                <a:ea typeface="CMU Serif Roman" panose="02000603000000000000" pitchFamily="2" charset="0"/>
+                <a:cs typeface="CMU Serif Roman" panose="02000603000000000000" pitchFamily="2" charset="0"/>
+              </a:rPr>
               <a:t>January 2025</a:t>
             </a:r>
           </a:p>
@@ -5344,7 +5357,7 @@
         </p:nvSpPr>
         <p:spPr>
           <a:xfrm>
-            <a:off x="8993053" y="6149249"/>
+            <a:off x="9279392" y="5691827"/>
             <a:ext cx="2912608" cy="457073"/>
           </a:xfrm>
         </p:spPr>
@@ -5364,6 +5377,9 @@
                     <a:lumMod val="50000"/>
                   </a:schemeClr>
                 </a:solidFill>
+                <a:latin typeface="CMU Serif Roman" panose="02000603000000000000" pitchFamily="2" charset="0"/>
+                <a:ea typeface="CMU Serif Roman" panose="02000603000000000000" pitchFamily="2" charset="0"/>
+                <a:cs typeface="CMU Serif Roman" panose="02000603000000000000" pitchFamily="2" charset="0"/>
               </a:rPr>
               <a:t>arXiv:2501.12948v2</a:t>
             </a:r>
@@ -5375,6 +5391,9 @@
                   <a:lumMod val="50000"/>
                 </a:schemeClr>
               </a:solidFill>
+              <a:latin typeface="CMU Serif Roman" panose="02000603000000000000" pitchFamily="2" charset="0"/>
+              <a:ea typeface="CMU Serif Roman" panose="02000603000000000000" pitchFamily="2" charset="0"/>
+              <a:cs typeface="CMU Serif Roman" panose="02000603000000000000" pitchFamily="2" charset="0"/>
             </a:endParaRPr>
           </a:p>
           <a:p>
@@ -5384,6 +5403,9 @@
                   <a:lumMod val="50000"/>
                 </a:schemeClr>
               </a:solidFill>
+              <a:latin typeface="CMU Serif Roman" panose="02000603000000000000" pitchFamily="2" charset="0"/>
+              <a:ea typeface="CMU Serif Roman" panose="02000603000000000000" pitchFamily="2" charset="0"/>
+              <a:cs typeface="CMU Serif Roman" panose="02000603000000000000" pitchFamily="2" charset="0"/>
             </a:endParaRPr>
           </a:p>
         </p:txBody>
@@ -5440,7 +5462,11 @@
           <a:lstStyle/>
           <a:p>
             <a:r>
-              <a:rPr lang="en-GB" dirty="0"/>
+              <a:rPr lang="en-GB" dirty="0">
+                <a:latin typeface="CMU Serif Roman" panose="02000603000000000000" pitchFamily="2" charset="0"/>
+                <a:ea typeface="CMU Serif Roman" panose="02000603000000000000" pitchFamily="2" charset="0"/>
+                <a:cs typeface="CMU Serif Roman" panose="02000603000000000000" pitchFamily="2" charset="0"/>
+              </a:rPr>
               <a:t>Instruction tuning</a:t>
             </a:r>
           </a:p>
@@ -5473,26 +5499,28 @@
               <a:buNone/>
             </a:pPr>
             <a:r>
-              <a:rPr lang="en-GB" dirty="0"/>
+              <a:rPr lang="en-GB" dirty="0">
+                <a:latin typeface="CMU Serif Roman" panose="02000603000000000000" pitchFamily="2" charset="0"/>
+                <a:ea typeface="CMU Serif Roman" panose="02000603000000000000" pitchFamily="2" charset="0"/>
+                <a:cs typeface="CMU Serif Roman" panose="02000603000000000000" pitchFamily="2" charset="0"/>
+              </a:rPr>
               <a:t>We can structure our data as a </a:t>
             </a:r>
             <a:r>
-              <a:rPr lang="en-GB" err="1">
-                <a:latin typeface="Consolas"/>
-                <a:ea typeface="Source Sans Pro"/>
+              <a:rPr lang="en-GB" dirty="0" err="1">
+                <a:latin typeface="CMU Serif Roman" panose="02000603000000000000" pitchFamily="2" charset="0"/>
+                <a:ea typeface="CMU Serif Roman" panose="02000603000000000000" pitchFamily="2" charset="0"/>
+                <a:cs typeface="CMU Serif Roman" panose="02000603000000000000" pitchFamily="2" charset="0"/>
               </a:rPr>
               <a:t>jsonl</a:t>
             </a:r>
             <a:r>
               <a:rPr lang="en-GB" dirty="0">
-                <a:latin typeface="Aptos"/>
-                <a:ea typeface="Source Sans Pro"/>
+                <a:latin typeface="CMU Serif Roman" panose="02000603000000000000" pitchFamily="2" charset="0"/>
+                <a:ea typeface="CMU Serif Roman" panose="02000603000000000000" pitchFamily="2" charset="0"/>
+                <a:cs typeface="CMU Serif Roman" panose="02000603000000000000" pitchFamily="2" charset="0"/>
               </a:rPr>
-              <a:t> </a:t>
-            </a:r>
-            <a:r>
-              <a:rPr lang="en-GB" dirty="0"/>
-              <a:t>file</a:t>
+              <a:t> file</a:t>
             </a:r>
           </a:p>
           <a:p>
@@ -5556,7 +5584,7 @@
               </a:rPr>
               <a:t>            {"role": "system", "content": "You are an expert in baking."},</a:t>
             </a:r>
-            <a:endParaRPr lang="en-GB" sz="1800">
+            <a:endParaRPr lang="en-GB" sz="1800" dirty="0">
               <a:latin typeface="Consolas"/>
             </a:endParaRPr>
           </a:p>
@@ -5673,7 +5701,11 @@
           <a:lstStyle/>
           <a:p>
             <a:r>
-              <a:rPr lang="en-GB" dirty="0"/>
+              <a:rPr lang="en-GB" dirty="0">
+                <a:latin typeface="CMU Serif Roman" panose="02000603000000000000" pitchFamily="2" charset="0"/>
+                <a:ea typeface="CMU Serif Roman" panose="02000603000000000000" pitchFamily="2" charset="0"/>
+                <a:cs typeface="CMU Serif Roman" panose="02000603000000000000" pitchFamily="2" charset="0"/>
+              </a:rPr>
               <a:t>Instruction tuning</a:t>
             </a:r>
           </a:p>
@@ -5764,7 +5796,7 @@
             <a:r>
               <a:rPr lang="en-GB" sz="1700" dirty="0">
                 <a:solidFill>
-                  <a:srgbClr val="0B7743"/>
+                  <a:srgbClr val="1B55EB"/>
                 </a:solidFill>
                 <a:latin typeface="Source Code Pro"/>
                 <a:ea typeface="Source Code Pro"/>
@@ -5919,7 +5951,7 @@
             <a:r>
               <a:rPr lang="en-GB" sz="1700" dirty="0">
                 <a:solidFill>
-                  <a:srgbClr val="0B7743"/>
+                  <a:srgbClr val="1B55EB"/>
                 </a:solidFill>
                 <a:latin typeface="Source Code Pro"/>
                 <a:ea typeface="Source Code Pro"/>
@@ -6084,7 +6116,7 @@
             <a:r>
               <a:rPr lang="en-GB" sz="1700" dirty="0">
                 <a:solidFill>
-                  <a:srgbClr val="0B7743"/>
+                  <a:srgbClr val="1B55EB"/>
                 </a:solidFill>
                 <a:latin typeface="Source Code Pro"/>
                 <a:ea typeface="Source Code Pro"/>
@@ -6327,7 +6359,11 @@
           <a:p>
             <a:pPr algn="l"/>
             <a:r>
-              <a:rPr lang="en-GB" dirty="0"/>
+              <a:rPr lang="en-GB" dirty="0">
+                <a:latin typeface="CMU Serif Roman" panose="02000603000000000000" pitchFamily="2" charset="0"/>
+                <a:ea typeface="CMU Serif Roman" panose="02000603000000000000" pitchFamily="2" charset="0"/>
+                <a:cs typeface="CMU Serif Roman" panose="02000603000000000000" pitchFamily="2" charset="0"/>
+              </a:rPr>
               <a:t>input</a:t>
             </a:r>
           </a:p>
@@ -6366,10 +6402,18 @@
           <a:p>
             <a:pPr algn="l"/>
             <a:r>
-              <a:rPr lang="en-GB" dirty="0"/>
+              <a:rPr lang="en-GB" dirty="0">
+                <a:latin typeface="CMU Serif Roman" panose="02000603000000000000" pitchFamily="2" charset="0"/>
+                <a:ea typeface="CMU Serif Roman" panose="02000603000000000000" pitchFamily="2" charset="0"/>
+                <a:cs typeface="CMU Serif Roman" panose="02000603000000000000" pitchFamily="2" charset="0"/>
+              </a:rPr>
               <a:t>generation</a:t>
             </a:r>
-            <a:endParaRPr lang="en-US" dirty="0"/>
+            <a:endParaRPr lang="en-US" dirty="0">
+              <a:latin typeface="CMU Serif Roman" panose="02000603000000000000" pitchFamily="2" charset="0"/>
+              <a:ea typeface="CMU Serif Roman" panose="02000603000000000000" pitchFamily="2" charset="0"/>
+              <a:cs typeface="CMU Serif Roman" panose="02000603000000000000" pitchFamily="2" charset="0"/>
+            </a:endParaRPr>
           </a:p>
         </p:txBody>
       </p:sp>
@@ -6549,7 +6593,11 @@
           <a:lstStyle/>
           <a:p>
             <a:r>
-              <a:rPr lang="en-GB" dirty="0"/>
+              <a:rPr lang="en-GB" dirty="0">
+                <a:latin typeface="CMU Serif Roman" panose="02000603000000000000" pitchFamily="2" charset="0"/>
+                <a:ea typeface="CMU Serif Roman" panose="02000603000000000000" pitchFamily="2" charset="0"/>
+                <a:cs typeface="CMU Serif Roman" panose="02000603000000000000" pitchFamily="2" charset="0"/>
+              </a:rPr>
               <a:t>Instruction tuning</a:t>
             </a:r>
           </a:p>
@@ -6571,7 +6619,12 @@
             <p:ph idx="1"/>
           </p:nvPr>
         </p:nvSpPr>
-        <p:spPr/>
+        <p:spPr>
+          <a:xfrm>
+            <a:off x="838200" y="1690688"/>
+            <a:ext cx="10515600" cy="4351338"/>
+          </a:xfrm>
+        </p:spPr>
         <p:txBody>
           <a:bodyPr vert="horz" lIns="91440" tIns="45720" rIns="91440" bIns="45720" rtlCol="0" anchor="t">
             <a:normAutofit/>
@@ -6582,7 +6635,11 @@
               <a:buNone/>
             </a:pPr>
             <a:r>
-              <a:rPr lang="en-GB" dirty="0"/>
+              <a:rPr lang="en-GB" dirty="0">
+                <a:latin typeface="CMU Serif Roman" panose="02000603000000000000" pitchFamily="2" charset="0"/>
+                <a:ea typeface="CMU Serif Roman" panose="02000603000000000000" pitchFamily="2" charset="0"/>
+                <a:cs typeface="CMU Serif Roman" panose="02000603000000000000" pitchFamily="2" charset="0"/>
+              </a:rPr>
               <a:t>Still next token generation</a:t>
             </a:r>
           </a:p>
@@ -6590,14 +6647,22 @@
             <a:pPr marL="0" indent="0">
               <a:buNone/>
             </a:pPr>
-            <a:endParaRPr lang="en-GB" dirty="0"/>
+            <a:endParaRPr lang="en-GB" dirty="0">
+              <a:latin typeface="CMU Serif Roman" panose="02000603000000000000" pitchFamily="2" charset="0"/>
+              <a:ea typeface="CMU Serif Roman" panose="02000603000000000000" pitchFamily="2" charset="0"/>
+              <a:cs typeface="CMU Serif Roman" panose="02000603000000000000" pitchFamily="2" charset="0"/>
+            </a:endParaRPr>
           </a:p>
           <a:p>
             <a:pPr marL="0" indent="0">
               <a:buNone/>
             </a:pPr>
             <a:r>
-              <a:rPr lang="en-GB" dirty="0"/>
+              <a:rPr lang="en-GB" dirty="0">
+                <a:latin typeface="CMU Serif Roman" panose="02000603000000000000" pitchFamily="2" charset="0"/>
+                <a:ea typeface="CMU Serif Roman" panose="02000603000000000000" pitchFamily="2" charset="0"/>
+                <a:cs typeface="CMU Serif Roman" panose="02000603000000000000" pitchFamily="2" charset="0"/>
+              </a:rPr>
               <a:t>This "template" is very important</a:t>
             </a:r>
           </a:p>
@@ -6605,14 +6670,22 @@
             <a:pPr marL="0" indent="0">
               <a:buNone/>
             </a:pPr>
-            <a:endParaRPr lang="en-GB" dirty="0"/>
+            <a:endParaRPr lang="en-GB" dirty="0">
+              <a:latin typeface="CMU Serif Roman" panose="02000603000000000000" pitchFamily="2" charset="0"/>
+              <a:ea typeface="CMU Serif Roman" panose="02000603000000000000" pitchFamily="2" charset="0"/>
+              <a:cs typeface="CMU Serif Roman" panose="02000603000000000000" pitchFamily="2" charset="0"/>
+            </a:endParaRPr>
           </a:p>
           <a:p>
             <a:pPr marL="0" indent="0">
               <a:buNone/>
             </a:pPr>
             <a:r>
-              <a:rPr lang="en-GB" dirty="0"/>
+              <a:rPr lang="en-GB" dirty="0">
+                <a:latin typeface="CMU Serif Roman" panose="02000603000000000000" pitchFamily="2" charset="0"/>
+                <a:ea typeface="CMU Serif Roman" panose="02000603000000000000" pitchFamily="2" charset="0"/>
+                <a:cs typeface="CMU Serif Roman" panose="02000603000000000000" pitchFamily="2" charset="0"/>
+              </a:rPr>
               <a:t>Deviate from the template during inference, and you'll get poor results</a:t>
             </a:r>
           </a:p>
@@ -6620,14 +6693,22 @@
             <a:pPr marL="0" indent="0">
               <a:buNone/>
             </a:pPr>
-            <a:endParaRPr lang="en-GB" dirty="0"/>
+            <a:endParaRPr lang="en-GB" dirty="0">
+              <a:latin typeface="CMU Serif Roman" panose="02000603000000000000" pitchFamily="2" charset="0"/>
+              <a:ea typeface="CMU Serif Roman" panose="02000603000000000000" pitchFamily="2" charset="0"/>
+              <a:cs typeface="CMU Serif Roman" panose="02000603000000000000" pitchFamily="2" charset="0"/>
+            </a:endParaRPr>
           </a:p>
           <a:p>
             <a:pPr marL="0" indent="0">
               <a:buNone/>
             </a:pPr>
             <a:r>
-              <a:rPr lang="en-GB" dirty="0"/>
+              <a:rPr lang="en-GB" dirty="0">
+                <a:latin typeface="CMU Serif Roman" panose="02000603000000000000" pitchFamily="2" charset="0"/>
+                <a:ea typeface="CMU Serif Roman" panose="02000603000000000000" pitchFamily="2" charset="0"/>
+                <a:cs typeface="CMU Serif Roman" panose="02000603000000000000" pitchFamily="2" charset="0"/>
+              </a:rPr>
               <a:t>The pattern is also important (system, user, assistant, user, assistant, …)</a:t>
             </a:r>
           </a:p>
@@ -6690,14 +6771,18 @@
           <a:lstStyle/>
           <a:p>
             <a:r>
-              <a:rPr lang="en-US" dirty="0"/>
+              <a:rPr lang="en-US" dirty="0">
+                <a:latin typeface="CMU Serif Roman" panose="02000603000000000000" pitchFamily="2" charset="0"/>
+                <a:ea typeface="CMU Serif Roman" panose="02000603000000000000" pitchFamily="2" charset="0"/>
+                <a:cs typeface="CMU Serif Roman" panose="02000603000000000000" pitchFamily="2" charset="0"/>
+              </a:rPr>
               <a:t>Full fine-tuning (FFT)</a:t>
             </a:r>
           </a:p>
         </p:txBody>
       </p:sp>
-      <mc:AlternateContent xmlns:mc="http://schemas.openxmlformats.org/markup-compatibility/2006" xmlns:a14="http://schemas.microsoft.com/office/drawing/2010/main">
-        <mc:Choice Requires="a14">
+      <mc:AlternateContent xmlns:mc="http://schemas.openxmlformats.org/markup-compatibility/2006">
+        <mc:Choice xmlns:a14="http://schemas.microsoft.com/office/drawing/2010/main" Requires="a14">
           <p:sp>
             <p:nvSpPr>
               <p:cNvPr id="5" name="Content Placeholder 2">
@@ -6716,7 +6801,7 @@
             </p:nvSpPr>
             <p:spPr>
               <a:xfrm>
-                <a:off x="838200" y="1825624"/>
+                <a:off x="838200" y="1690688"/>
                 <a:ext cx="10515600" cy="5032375"/>
               </a:xfrm>
             </p:spPr>
@@ -6730,58 +6815,106 @@
                   <a:buNone/>
                 </a:pPr>
                 <a:r>
-                  <a:rPr lang="en-US" dirty="0"/>
-                  <a:t>Checking the till…</a:t>
+                  <a:rPr lang="en-US" dirty="0">
+                    <a:latin typeface="CMU Serif Roman" panose="02000603000000000000" pitchFamily="2" charset="0"/>
+                    <a:ea typeface="CMU Serif Roman" panose="02000603000000000000" pitchFamily="2" charset="0"/>
+                    <a:cs typeface="CMU Serif Roman" panose="02000603000000000000" pitchFamily="2" charset="0"/>
+                  </a:rPr>
+                  <a:t>Checking the </a:t>
+                </a:r>
+                <a:r>
+                  <a:rPr lang="en-US" dirty="0">
+                    <a:latin typeface="CMU Serif Roman" panose="02000603000000000000" pitchFamily="2" charset="0"/>
+                    <a:ea typeface="CMU Serif Roman" panose="02000603000000000000" pitchFamily="2" charset="0"/>
+                    <a:cs typeface="CMU Serif Roman" panose="02000603000000000000" pitchFamily="2" charset="0"/>
+                  </a:rPr>
+                  <a:t>till…</a:t>
                 </a:r>
               </a:p>
               <a:p>
                 <a:pPr marL="0" indent="0">
                   <a:buNone/>
                 </a:pPr>
-                <a:endParaRPr lang="en-US" dirty="0"/>
+                <a:endParaRPr lang="en-US" dirty="0">
+                  <a:latin typeface="CMU Serif Roman" panose="02000603000000000000" pitchFamily="2" charset="0"/>
+                  <a:ea typeface="CMU Serif Roman" panose="02000603000000000000" pitchFamily="2" charset="0"/>
+                  <a:cs typeface="CMU Serif Roman" panose="02000603000000000000" pitchFamily="2" charset="0"/>
+                </a:endParaRPr>
               </a:p>
               <a:p>
                 <a:r>
-                  <a:rPr lang="en-US" dirty="0"/>
+                  <a:rPr lang="en-US" dirty="0">
+                    <a:latin typeface="CMU Serif Roman" panose="02000603000000000000" pitchFamily="2" charset="0"/>
+                    <a:ea typeface="CMU Serif Roman" panose="02000603000000000000" pitchFamily="2" charset="0"/>
+                    <a:cs typeface="CMU Serif Roman" panose="02000603000000000000" pitchFamily="2" charset="0"/>
+                  </a:rPr>
                   <a:t>When we update the base model weights we need, per parameter:</a:t>
                 </a:r>
               </a:p>
               <a:p>
                 <a:pPr lvl="1"/>
                 <a:r>
-                  <a:rPr lang="en-US" dirty="0"/>
+                  <a:rPr lang="en-US" dirty="0">
+                    <a:latin typeface="CMU Serif Roman" panose="02000603000000000000" pitchFamily="2" charset="0"/>
+                    <a:ea typeface="CMU Serif Roman" panose="02000603000000000000" pitchFamily="2" charset="0"/>
+                    <a:cs typeface="CMU Serif Roman" panose="02000603000000000000" pitchFamily="2" charset="0"/>
+                  </a:rPr>
                   <a:t>Weights, gradients, first and second moments of Adam </a:t>
                 </a:r>
                 <a:r>
-                  <a:rPr lang="en-US" dirty="0" err="1"/>
+                  <a:rPr lang="en-US" dirty="0" err="1">
+                    <a:latin typeface="CMU Serif Roman" panose="02000603000000000000" pitchFamily="2" charset="0"/>
+                    <a:ea typeface="CMU Serif Roman" panose="02000603000000000000" pitchFamily="2" charset="0"/>
+                    <a:cs typeface="CMU Serif Roman" panose="02000603000000000000" pitchFamily="2" charset="0"/>
+                  </a:rPr>
                   <a:t>optimiser</a:t>
                 </a:r>
                 <a:r>
-                  <a:rPr lang="en-US" dirty="0"/>
+                  <a:rPr lang="en-US" dirty="0">
+                    <a:latin typeface="CMU Serif Roman" panose="02000603000000000000" pitchFamily="2" charset="0"/>
+                    <a:ea typeface="CMU Serif Roman" panose="02000603000000000000" pitchFamily="2" charset="0"/>
+                    <a:cs typeface="CMU Serif Roman" panose="02000603000000000000" pitchFamily="2" charset="0"/>
+                  </a:rPr>
                   <a:t> state</a:t>
                 </a:r>
               </a:p>
               <a:p>
                 <a:pPr lvl="1"/>
                 <a:r>
-                  <a:rPr lang="en-US" dirty="0"/>
+                  <a:rPr lang="en-US" dirty="0">
+                    <a:latin typeface="CMU Serif Roman" panose="02000603000000000000" pitchFamily="2" charset="0"/>
+                    <a:ea typeface="CMU Serif Roman" panose="02000603000000000000" pitchFamily="2" charset="0"/>
+                    <a:cs typeface="CMU Serif Roman" panose="02000603000000000000" pitchFamily="2" charset="0"/>
+                  </a:rPr>
                   <a:t>So, roughly 4 copies of the model</a:t>
                 </a:r>
               </a:p>
               <a:p>
                 <a:r>
-                  <a:rPr lang="en-GB" i="1" dirty="0"/>
+                  <a:rPr lang="en-GB" i="1" dirty="0">
+                    <a:latin typeface="CMU SERIF ROMAN" panose="02000603000000000000" pitchFamily="2" charset="0"/>
+                    <a:ea typeface="CMU SERIF ROMAN" panose="02000603000000000000" pitchFamily="2" charset="0"/>
+                    <a:cs typeface="CMU SERIF ROMAN" panose="02000603000000000000" pitchFamily="2" charset="0"/>
+                  </a:rPr>
                   <a:t>Llama 3.1 70B</a:t>
                 </a:r>
               </a:p>
               <a:p>
                 <a:pPr lvl="1"/>
                 <a:r>
-                  <a:rPr lang="en-GB" b="0" dirty="0"/>
+                  <a:rPr lang="en-GB" b="0" dirty="0">
+                    <a:latin typeface="CMU Serif Roman" panose="02000603000000000000" pitchFamily="2" charset="0"/>
+                    <a:ea typeface="CMU Serif Roman" panose="02000603000000000000" pitchFamily="2" charset="0"/>
+                    <a:cs typeface="CMU Serif Roman" panose="02000603000000000000" pitchFamily="2" charset="0"/>
+                  </a:rPr>
                   <a:t>For bf16 / fp16</a:t>
                 </a:r>
                 <a:r>
-                  <a:rPr lang="en-GB" dirty="0"/>
+                  <a:rPr lang="en-GB" dirty="0">
+                    <a:latin typeface="CMU Serif Roman" panose="02000603000000000000" pitchFamily="2" charset="0"/>
+                    <a:ea typeface="CMU Serif Roman" panose="02000603000000000000" pitchFamily="2" charset="0"/>
+                    <a:cs typeface="CMU Serif Roman" panose="02000603000000000000" pitchFamily="2" charset="0"/>
+                  </a:rPr>
                   <a:t>, that’s </a:t>
                 </a:r>
                 <a14:m>
@@ -6795,31 +6928,47 @@
                   </m:oMath>
                 </a14:m>
                 <a:r>
-                  <a:rPr lang="en-GB" b="0" dirty="0"/>
+                  <a:rPr lang="en-GB" b="0" dirty="0">
+                    <a:latin typeface="CMU Serif Roman" panose="02000603000000000000" pitchFamily="2" charset="0"/>
+                    <a:ea typeface="CMU Serif Roman" panose="02000603000000000000" pitchFamily="2" charset="0"/>
+                    <a:cs typeface="CMU Serif Roman" panose="02000603000000000000" pitchFamily="2" charset="0"/>
+                  </a:rPr>
                   <a:t> bytes per parameter.</a:t>
                 </a:r>
               </a:p>
               <a:p>
                 <a:pPr lvl="1"/>
                 <a:r>
-                  <a:rPr lang="en-GB" dirty="0"/>
+                  <a:rPr lang="en-GB" dirty="0">
+                    <a:latin typeface="CMU Serif Roman" panose="02000603000000000000" pitchFamily="2" charset="0"/>
+                    <a:ea typeface="CMU Serif Roman" panose="02000603000000000000" pitchFamily="2" charset="0"/>
+                    <a:cs typeface="CMU Serif Roman" panose="02000603000000000000" pitchFamily="2" charset="0"/>
+                  </a:rPr>
                   <a:t>~560GB total!</a:t>
                 </a:r>
               </a:p>
               <a:p>
                 <a:r>
-                  <a:rPr lang="en-GB" b="0" dirty="0"/>
+                  <a:rPr lang="en-GB" b="0" dirty="0">
+                    <a:latin typeface="CMU Serif Roman" panose="02000603000000000000" pitchFamily="2" charset="0"/>
+                    <a:ea typeface="CMU Serif Roman" panose="02000603000000000000" pitchFamily="2" charset="0"/>
+                    <a:cs typeface="CMU Serif Roman" panose="02000603000000000000" pitchFamily="2" charset="0"/>
+                  </a:rPr>
                   <a:t>Or 7 NVIDIA H100s…</a:t>
                 </a:r>
               </a:p>
               <a:p>
                 <a:pPr lvl="1"/>
-                <a:endParaRPr lang="en-GB" b="0" dirty="0"/>
+                <a:endParaRPr lang="en-GB" b="0" dirty="0">
+                  <a:latin typeface="CMU Serif Roman" panose="02000603000000000000" pitchFamily="2" charset="0"/>
+                  <a:ea typeface="CMU Serif Roman" panose="02000603000000000000" pitchFamily="2" charset="0"/>
+                  <a:cs typeface="CMU Serif Roman" panose="02000603000000000000" pitchFamily="2" charset="0"/>
+                </a:endParaRPr>
               </a:p>
             </p:txBody>
           </p:sp>
         </mc:Choice>
-        <mc:Fallback xmlns="">
+        <mc:Fallback>
           <p:sp>
             <p:nvSpPr>
               <p:cNvPr id="5" name="Content Placeholder 2">
@@ -6838,13 +6987,13 @@
             </p:nvSpPr>
             <p:spPr>
               <a:xfrm>
-                <a:off x="838200" y="1825624"/>
+                <a:off x="838200" y="1690688"/>
                 <a:ext cx="10515600" cy="5032375"/>
               </a:xfrm>
               <a:blipFill>
                 <a:blip r:embed="rId3"/>
                 <a:stretch>
-                  <a:fillRect l="-1206" t="-2015" r="-724"/>
+                  <a:fillRect l="-1206" t="-1759"/>
                 </a:stretch>
               </a:blipFill>
             </p:spPr>
@@ -6885,7 +7034,7 @@
         </p:blipFill>
         <p:spPr>
           <a:xfrm>
-            <a:off x="3478695" y="4162148"/>
+            <a:off x="3548364" y="4397279"/>
             <a:ext cx="638802" cy="359326"/>
           </a:xfrm>
           <a:prstGeom prst="rect">
@@ -6950,22 +7099,34 @@
           <a:lstStyle/>
           <a:p>
             <a:r>
-              <a:rPr lang="en-US" dirty="0"/>
+              <a:rPr lang="en-US" dirty="0">
+                <a:latin typeface="CMU Serif Roman" panose="02000603000000000000" pitchFamily="2" charset="0"/>
+                <a:ea typeface="CMU Serif Roman" panose="02000603000000000000" pitchFamily="2" charset="0"/>
+                <a:cs typeface="CMU Serif Roman" panose="02000603000000000000" pitchFamily="2" charset="0"/>
+              </a:rPr>
               <a:t>Low Rank Adaptation (</a:t>
             </a:r>
             <a:r>
-              <a:rPr lang="en-US" dirty="0" err="1"/>
+              <a:rPr lang="en-US" dirty="0" err="1">
+                <a:latin typeface="CMU Serif Roman" panose="02000603000000000000" pitchFamily="2" charset="0"/>
+                <a:ea typeface="CMU Serif Roman" panose="02000603000000000000" pitchFamily="2" charset="0"/>
+                <a:cs typeface="CMU Serif Roman" panose="02000603000000000000" pitchFamily="2" charset="0"/>
+              </a:rPr>
               <a:t>LoRA</a:t>
             </a:r>
             <a:r>
-              <a:rPr lang="en-US" dirty="0"/>
+              <a:rPr lang="en-US" dirty="0">
+                <a:latin typeface="CMU Serif Roman" panose="02000603000000000000" pitchFamily="2" charset="0"/>
+                <a:ea typeface="CMU Serif Roman" panose="02000603000000000000" pitchFamily="2" charset="0"/>
+                <a:cs typeface="CMU Serif Roman" panose="02000603000000000000" pitchFamily="2" charset="0"/>
+              </a:rPr>
               <a:t>)</a:t>
             </a:r>
           </a:p>
         </p:txBody>
       </p:sp>
-      <mc:AlternateContent xmlns:mc="http://schemas.openxmlformats.org/markup-compatibility/2006" xmlns:a14="http://schemas.microsoft.com/office/drawing/2010/main">
-        <mc:Choice Requires="a14">
+      <mc:AlternateContent xmlns:mc="http://schemas.openxmlformats.org/markup-compatibility/2006">
+        <mc:Choice xmlns:a14="http://schemas.microsoft.com/office/drawing/2010/main" Requires="a14">
           <p:sp>
             <p:nvSpPr>
               <p:cNvPr id="5" name="Content Placeholder 2">
@@ -6995,15 +7156,27 @@
               <a:lstStyle/>
               <a:p>
                 <a:r>
-                  <a:rPr lang="en-US" dirty="0"/>
+                  <a:rPr lang="en-US" dirty="0">
+                    <a:latin typeface="CMU Serif Roman" panose="02000603000000000000" pitchFamily="2" charset="0"/>
+                    <a:ea typeface="CMU Serif Roman" panose="02000603000000000000" pitchFamily="2" charset="0"/>
+                    <a:cs typeface="CMU Serif Roman" panose="02000603000000000000" pitchFamily="2" charset="0"/>
+                  </a:rPr>
                   <a:t>At each </a:t>
                 </a:r>
                 <a:r>
-                  <a:rPr lang="en-US" dirty="0" err="1"/>
+                  <a:rPr lang="en-US" dirty="0" err="1">
+                    <a:latin typeface="CMU Serif Roman" panose="02000603000000000000" pitchFamily="2" charset="0"/>
+                    <a:ea typeface="CMU Serif Roman" panose="02000603000000000000" pitchFamily="2" charset="0"/>
+                    <a:cs typeface="CMU Serif Roman" panose="02000603000000000000" pitchFamily="2" charset="0"/>
+                  </a:rPr>
                   <a:t>optimiser</a:t>
                 </a:r>
                 <a:r>
-                  <a:rPr lang="en-US" dirty="0"/>
+                  <a:rPr lang="en-US" dirty="0">
+                    <a:latin typeface="CMU Serif Roman" panose="02000603000000000000" pitchFamily="2" charset="0"/>
+                    <a:ea typeface="CMU Serif Roman" panose="02000603000000000000" pitchFamily="2" charset="0"/>
+                    <a:cs typeface="CMU Serif Roman" panose="02000603000000000000" pitchFamily="2" charset="0"/>
+                  </a:rPr>
                   <a:t> step, instead of updating:</a:t>
                 </a:r>
               </a:p>
@@ -7011,7 +7184,11 @@
                 <a:pPr marL="0" indent="0">
                   <a:buNone/>
                 </a:pPr>
-                <a:endParaRPr lang="en-US" dirty="0"/>
+                <a:endParaRPr lang="en-US" dirty="0">
+                  <a:latin typeface="CMU Serif Roman" panose="02000603000000000000" pitchFamily="2" charset="0"/>
+                  <a:ea typeface="CMU Serif Roman" panose="02000603000000000000" pitchFamily="2" charset="0"/>
+                  <a:cs typeface="CMU Serif Roman" panose="02000603000000000000" pitchFamily="2" charset="0"/>
+                </a:endParaRPr>
               </a:p>
               <a:p>
                 <a:pPr marL="0" indent="0">
@@ -7152,8 +7329,9 @@
                               <m:nor/>
                             </m:rPr>
                             <a:rPr lang="en-GB" b="0" i="0" smtClean="0">
-                              <a:latin typeface="Cambria Math" panose="02040503050406030204" pitchFamily="18" charset="0"/>
-                              <a:ea typeface="Cambria Math" panose="02040503050406030204" pitchFamily="18" charset="0"/>
+                              <a:latin typeface="CMU Serif Roman" panose="02000603000000000000" pitchFamily="2" charset="0"/>
+                              <a:ea typeface="CMU Serif Roman" panose="02000603000000000000" pitchFamily="2" charset="0"/>
+                              <a:cs typeface="CMU Serif Roman" panose="02000603000000000000" pitchFamily="2" charset="0"/>
                             </a:rPr>
                             <m:t>MLP</m:t>
                           </m:r>
@@ -7163,7 +7341,9 @@
                   </m:oMathPara>
                 </a14:m>
                 <a:endParaRPr lang="en-GB" b="0" dirty="0">
-                  <a:ea typeface="Cambria Math" panose="02040503050406030204" pitchFamily="18" charset="0"/>
+                  <a:latin typeface="CMU Serif Roman" panose="02000603000000000000" pitchFamily="2" charset="0"/>
+                  <a:ea typeface="CMU Serif Roman" panose="02000603000000000000" pitchFamily="2" charset="0"/>
+                  <a:cs typeface="CMU Serif Roman" panose="02000603000000000000" pitchFamily="2" charset="0"/>
                 </a:endParaRPr>
               </a:p>
               <a:p>
@@ -7171,13 +7351,17 @@
                   <a:buNone/>
                 </a:pPr>
                 <a:endParaRPr lang="en-GB" b="0" dirty="0">
-                  <a:ea typeface="Cambria Math" panose="02040503050406030204" pitchFamily="18" charset="0"/>
+                  <a:latin typeface="CMU Serif Roman" panose="02000603000000000000" pitchFamily="2" charset="0"/>
+                  <a:ea typeface="CMU Serif Roman" panose="02000603000000000000" pitchFamily="2" charset="0"/>
+                  <a:cs typeface="CMU Serif Roman" panose="02000603000000000000" pitchFamily="2" charset="0"/>
                 </a:endParaRPr>
               </a:p>
               <a:p>
                 <a:r>
                   <a:rPr lang="en-GB" b="0" dirty="0">
-                    <a:ea typeface="Cambria Math" panose="02040503050406030204" pitchFamily="18" charset="0"/>
+                    <a:latin typeface="CMU Serif Roman" panose="02000603000000000000" pitchFamily="2" charset="0"/>
+                    <a:ea typeface="CMU Serif Roman" panose="02000603000000000000" pitchFamily="2" charset="0"/>
+                    <a:cs typeface="CMU Serif Roman" panose="02000603000000000000" pitchFamily="2" charset="0"/>
                   </a:rPr>
                   <a:t>For a given weight matrix </a:t>
                 </a:r>
@@ -7197,7 +7381,9 @@
                 </a14:m>
                 <a:r>
                   <a:rPr lang="en-GB" b="0" dirty="0">
-                    <a:ea typeface="Cambria Math" panose="02040503050406030204" pitchFamily="18" charset="0"/>
+                    <a:latin typeface="CMU Serif Roman" panose="02000603000000000000" pitchFamily="2" charset="0"/>
+                    <a:ea typeface="CMU Serif Roman" panose="02000603000000000000" pitchFamily="2" charset="0"/>
+                    <a:cs typeface="CMU Serif Roman" panose="02000603000000000000" pitchFamily="2" charset="0"/>
                   </a:rPr>
                   <a:t>, </a:t>
                 </a:r>
@@ -7206,13 +7392,17 @@
                     <a:solidFill>
                       <a:schemeClr val="accent4"/>
                     </a:solidFill>
-                    <a:ea typeface="Cambria Math" panose="02040503050406030204" pitchFamily="18" charset="0"/>
+                    <a:latin typeface="CMU Serif Roman" panose="02000603000000000000" pitchFamily="2" charset="0"/>
+                    <a:ea typeface="CMU Serif Roman" panose="02000603000000000000" pitchFamily="2" charset="0"/>
+                    <a:cs typeface="CMU Serif Roman" panose="02000603000000000000" pitchFamily="2" charset="0"/>
                   </a:rPr>
                   <a:t>freeze</a:t>
                 </a:r>
                 <a:r>
                   <a:rPr lang="en-GB" b="0" dirty="0">
-                    <a:ea typeface="Cambria Math" panose="02040503050406030204" pitchFamily="18" charset="0"/>
+                    <a:latin typeface="CMU Serif Roman" panose="02000603000000000000" pitchFamily="2" charset="0"/>
+                    <a:ea typeface="CMU Serif Roman" panose="02000603000000000000" pitchFamily="2" charset="0"/>
+                    <a:cs typeface="CMU Serif Roman" panose="02000603000000000000" pitchFamily="2" charset="0"/>
                   </a:rPr>
                   <a:t> the base weights and update an ‘adapter’ </a:t>
                 </a:r>
@@ -7239,14 +7429,18 @@
                 </a14:m>
                 <a:r>
                   <a:rPr lang="en-GB" b="0" dirty="0">
-                    <a:ea typeface="Cambria Math" panose="02040503050406030204" pitchFamily="18" charset="0"/>
+                    <a:latin typeface="CMU Serif Roman" panose="02000603000000000000" pitchFamily="2" charset="0"/>
+                    <a:ea typeface="CMU Serif Roman" panose="02000603000000000000" pitchFamily="2" charset="0"/>
+                    <a:cs typeface="CMU Serif Roman" panose="02000603000000000000" pitchFamily="2" charset="0"/>
                   </a:rPr>
                   <a:t>:</a:t>
                 </a:r>
               </a:p>
               <a:p>
                 <a:endParaRPr lang="en-GB" dirty="0">
-                  <a:ea typeface="Cambria Math" panose="02040503050406030204" pitchFamily="18" charset="0"/>
+                  <a:latin typeface="CMU Serif Roman" panose="02000603000000000000" pitchFamily="2" charset="0"/>
+                  <a:ea typeface="CMU Serif Roman" panose="02000603000000000000" pitchFamily="2" charset="0"/>
+                  <a:cs typeface="CMU Serif Roman" panose="02000603000000000000" pitchFamily="2" charset="0"/>
                 </a:endParaRPr>
               </a:p>
               <a:p>
@@ -7355,7 +7549,9 @@
                   </m:oMathPara>
                 </a14:m>
                 <a:endParaRPr lang="en-GB" b="0" dirty="0">
-                  <a:ea typeface="Cambria Math" panose="02040503050406030204" pitchFamily="18" charset="0"/>
+                  <a:latin typeface="CMU Serif Roman" panose="02000603000000000000" pitchFamily="2" charset="0"/>
+                  <a:ea typeface="CMU Serif Roman" panose="02000603000000000000" pitchFamily="2" charset="0"/>
+                  <a:cs typeface="CMU Serif Roman" panose="02000603000000000000" pitchFamily="2" charset="0"/>
                 </a:endParaRPr>
               </a:p>
               <a:p>
@@ -7363,7 +7559,9 @@
                   <a:buNone/>
                 </a:pPr>
                 <a:endParaRPr lang="en-GB" b="0" dirty="0">
-                  <a:ea typeface="Cambria Math" panose="02040503050406030204" pitchFamily="18" charset="0"/>
+                  <a:latin typeface="CMU Serif Roman" panose="02000603000000000000" pitchFamily="2" charset="0"/>
+                  <a:ea typeface="CMU Serif Roman" panose="02000603000000000000" pitchFamily="2" charset="0"/>
+                  <a:cs typeface="CMU Serif Roman" panose="02000603000000000000" pitchFamily="2" charset="0"/>
                 </a:endParaRPr>
               </a:p>
               <a:p>
@@ -7371,7 +7569,9 @@
                   <a:buNone/>
                 </a:pPr>
                 <a:endParaRPr lang="en-GB" b="0" dirty="0">
-                  <a:ea typeface="Cambria Math" panose="02040503050406030204" pitchFamily="18" charset="0"/>
+                  <a:latin typeface="CMU Serif Roman" panose="02000603000000000000" pitchFamily="2" charset="0"/>
+                  <a:ea typeface="CMU Serif Roman" panose="02000603000000000000" pitchFamily="2" charset="0"/>
+                  <a:cs typeface="CMU Serif Roman" panose="02000603000000000000" pitchFamily="2" charset="0"/>
                 </a:endParaRPr>
               </a:p>
               <a:p>
@@ -7379,7 +7579,9 @@
                   <a:buNone/>
                 </a:pPr>
                 <a:endParaRPr lang="en-GB" b="0" dirty="0">
-                  <a:ea typeface="Cambria Math" panose="02040503050406030204" pitchFamily="18" charset="0"/>
+                  <a:latin typeface="CMU Serif Roman" panose="02000603000000000000" pitchFamily="2" charset="0"/>
+                  <a:ea typeface="CMU Serif Roman" panose="02000603000000000000" pitchFamily="2" charset="0"/>
+                  <a:cs typeface="CMU Serif Roman" panose="02000603000000000000" pitchFamily="2" charset="0"/>
                 </a:endParaRPr>
               </a:p>
               <a:p>
@@ -7387,7 +7589,9 @@
                   <a:buNone/>
                 </a:pPr>
                 <a:endParaRPr lang="en-GB" b="0" dirty="0">
-                  <a:ea typeface="Cambria Math" panose="02040503050406030204" pitchFamily="18" charset="0"/>
+                  <a:latin typeface="CMU Serif Roman" panose="02000603000000000000" pitchFamily="2" charset="0"/>
+                  <a:ea typeface="CMU Serif Roman" panose="02000603000000000000" pitchFamily="2" charset="0"/>
+                  <a:cs typeface="CMU Serif Roman" panose="02000603000000000000" pitchFamily="2" charset="0"/>
                 </a:endParaRPr>
               </a:p>
               <a:p>
@@ -7395,29 +7599,39 @@
                   <a:buNone/>
                 </a:pPr>
                 <a:endParaRPr lang="en-GB" b="0" dirty="0">
-                  <a:ea typeface="Cambria Math" panose="02040503050406030204" pitchFamily="18" charset="0"/>
+                  <a:latin typeface="CMU Serif Roman" panose="02000603000000000000" pitchFamily="2" charset="0"/>
+                  <a:ea typeface="CMU Serif Roman" panose="02000603000000000000" pitchFamily="2" charset="0"/>
+                  <a:cs typeface="CMU Serif Roman" panose="02000603000000000000" pitchFamily="2" charset="0"/>
                 </a:endParaRPr>
               </a:p>
               <a:p>
                 <a:endParaRPr lang="en-GB" b="0" dirty="0">
-                  <a:ea typeface="Cambria Math" panose="02040503050406030204" pitchFamily="18" charset="0"/>
+                  <a:latin typeface="CMU Serif Roman" panose="02000603000000000000" pitchFamily="2" charset="0"/>
+                  <a:ea typeface="CMU Serif Roman" panose="02000603000000000000" pitchFamily="2" charset="0"/>
+                  <a:cs typeface="CMU Serif Roman" panose="02000603000000000000" pitchFamily="2" charset="0"/>
                 </a:endParaRPr>
               </a:p>
               <a:p>
                 <a:endParaRPr lang="en-GB" b="0" dirty="0">
-                  <a:ea typeface="Cambria Math" panose="02040503050406030204" pitchFamily="18" charset="0"/>
+                  <a:latin typeface="CMU Serif Roman" panose="02000603000000000000" pitchFamily="2" charset="0"/>
+                  <a:ea typeface="CMU Serif Roman" panose="02000603000000000000" pitchFamily="2" charset="0"/>
+                  <a:cs typeface="CMU Serif Roman" panose="02000603000000000000" pitchFamily="2" charset="0"/>
                 </a:endParaRPr>
               </a:p>
               <a:p>
                 <a:pPr marL="0" indent="0">
                   <a:buNone/>
                 </a:pPr>
-                <a:endParaRPr lang="en-US" dirty="0"/>
+                <a:endParaRPr lang="en-US" dirty="0">
+                  <a:latin typeface="CMU Serif Roman" panose="02000603000000000000" pitchFamily="2" charset="0"/>
+                  <a:ea typeface="CMU Serif Roman" panose="02000603000000000000" pitchFamily="2" charset="0"/>
+                  <a:cs typeface="CMU Serif Roman" panose="02000603000000000000" pitchFamily="2" charset="0"/>
+                </a:endParaRPr>
               </a:p>
             </p:txBody>
           </p:sp>
         </mc:Choice>
-        <mc:Fallback xmlns="">
+        <mc:Fallback>
           <p:sp>
             <p:nvSpPr>
               <p:cNvPr id="5" name="Content Placeholder 2">
@@ -7442,7 +7656,7 @@
               <a:blipFill>
                 <a:blip r:embed="rId3"/>
                 <a:stretch>
-                  <a:fillRect l="-1086" t="-2326"/>
+                  <a:fillRect l="-1086" t="-2035"/>
                 </a:stretch>
               </a:blipFill>
             </p:spPr>
@@ -7542,10 +7756,10 @@
       </p:sp>
       <p:sp>
         <p:nvSpPr>
-          <p:cNvPr id="8" name="Content Placeholder 2">
+          <p:cNvPr id="2" name="Content Placeholder 2">
             <a:extLst>
               <a:ext uri="{FF2B5EF4-FFF2-40B4-BE49-F238E27FC236}">
-                <a16:creationId xmlns:a16="http://schemas.microsoft.com/office/drawing/2014/main" id="{DD519F0B-4F5A-DBAF-AE43-C8E820D42AF8}"/>
+                <a16:creationId xmlns:a16="http://schemas.microsoft.com/office/drawing/2014/main" id="{58C05986-6B04-EB78-8119-C71B9DA29C06}"/>
               </a:ext>
             </a:extLst>
           </p:cNvPr>
@@ -7556,7 +7770,7 @@
         </p:nvSpPr>
         <p:spPr>
           <a:xfrm>
-            <a:off x="8740464" y="6158508"/>
+            <a:off x="9480692" y="5793804"/>
             <a:ext cx="3118738" cy="529390"/>
           </a:xfrm>
           <a:prstGeom prst="rect">
@@ -7743,6 +7957,9 @@
                     <a:lumOff val="50000"/>
                   </a:schemeClr>
                 </a:solidFill>
+                <a:latin typeface="CMU Serif Roman" panose="02000603000000000000" pitchFamily="2" charset="0"/>
+                <a:ea typeface="CMU Serif Roman" panose="02000603000000000000" pitchFamily="2" charset="0"/>
+                <a:cs typeface="CMU Serif Roman" panose="02000603000000000000" pitchFamily="2" charset="0"/>
               </a:rPr>
               <a:t>arXiv:2106.09685</a:t>
             </a:r>
@@ -7755,6 +7972,9 @@
                   <a:lumOff val="50000"/>
                 </a:schemeClr>
               </a:solidFill>
+              <a:latin typeface="CMU Serif Roman" panose="02000603000000000000" pitchFamily="2" charset="0"/>
+              <a:ea typeface="CMU Serif Roman" panose="02000603000000000000" pitchFamily="2" charset="0"/>
+              <a:cs typeface="CMU Serif Roman" panose="02000603000000000000" pitchFamily="2" charset="0"/>
             </a:endParaRPr>
           </a:p>
           <a:p>
@@ -7765,6 +7985,9 @@
                   <a:lumOff val="50000"/>
                 </a:schemeClr>
               </a:solidFill>
+              <a:latin typeface="CMU Serif Roman" panose="02000603000000000000" pitchFamily="2" charset="0"/>
+              <a:ea typeface="CMU Serif Roman" panose="02000603000000000000" pitchFamily="2" charset="0"/>
+              <a:cs typeface="CMU Serif Roman" panose="02000603000000000000" pitchFamily="2" charset="0"/>
             </a:endParaRPr>
           </a:p>
         </p:txBody>
@@ -8097,22 +8320,34 @@
           <a:lstStyle/>
           <a:p>
             <a:r>
-              <a:rPr lang="en-US" dirty="0"/>
+              <a:rPr lang="en-US" dirty="0">
+                <a:latin typeface="CMU Serif Roman" panose="02000603000000000000" pitchFamily="2" charset="0"/>
+                <a:ea typeface="CMU Serif Roman" panose="02000603000000000000" pitchFamily="2" charset="0"/>
+                <a:cs typeface="CMU Serif Roman" panose="02000603000000000000" pitchFamily="2" charset="0"/>
+              </a:rPr>
               <a:t>Low Rank Adaptation (</a:t>
             </a:r>
             <a:r>
-              <a:rPr lang="en-US" dirty="0" err="1"/>
+              <a:rPr lang="en-US" dirty="0" err="1">
+                <a:latin typeface="CMU Serif Roman" panose="02000603000000000000" pitchFamily="2" charset="0"/>
+                <a:ea typeface="CMU Serif Roman" panose="02000603000000000000" pitchFamily="2" charset="0"/>
+                <a:cs typeface="CMU Serif Roman" panose="02000603000000000000" pitchFamily="2" charset="0"/>
+              </a:rPr>
               <a:t>LoRA</a:t>
             </a:r>
             <a:r>
-              <a:rPr lang="en-US" dirty="0"/>
+              <a:rPr lang="en-US" dirty="0">
+                <a:latin typeface="CMU Serif Roman" panose="02000603000000000000" pitchFamily="2" charset="0"/>
+                <a:ea typeface="CMU Serif Roman" panose="02000603000000000000" pitchFamily="2" charset="0"/>
+                <a:cs typeface="CMU Serif Roman" panose="02000603000000000000" pitchFamily="2" charset="0"/>
+              </a:rPr>
               <a:t>)</a:t>
             </a:r>
           </a:p>
         </p:txBody>
       </p:sp>
-      <mc:AlternateContent xmlns:mc="http://schemas.openxmlformats.org/markup-compatibility/2006" xmlns:a14="http://schemas.microsoft.com/office/drawing/2010/main">
-        <mc:Choice Requires="a14">
+      <mc:AlternateContent xmlns:mc="http://schemas.openxmlformats.org/markup-compatibility/2006">
+        <mc:Choice xmlns:a14="http://schemas.microsoft.com/office/drawing/2010/main" Requires="a14">
           <p:sp>
             <p:nvSpPr>
               <p:cNvPr id="5" name="Content Placeholder 2">
@@ -8145,7 +8380,11 @@
                   <a:buNone/>
                 </a:pPr>
                 <a:r>
-                  <a:rPr lang="en-US" dirty="0"/>
+                  <a:rPr lang="en-US" dirty="0">
+                    <a:latin typeface="CMU Serif Roman" panose="02000603000000000000" pitchFamily="2" charset="0"/>
+                    <a:ea typeface="CMU Serif Roman" panose="02000603000000000000" pitchFamily="2" charset="0"/>
+                    <a:cs typeface="CMU Serif Roman" panose="02000603000000000000" pitchFamily="2" charset="0"/>
+                  </a:rPr>
                   <a:t>This is great, so long as we can make</a:t>
                 </a:r>
                 <a14:m>
@@ -8174,11 +8413,19 @@
                   </m:oMath>
                 </a14:m>
                 <a:r>
-                  <a:rPr lang="en-GB" b="0" dirty="0"/>
+                  <a:rPr lang="en-GB" b="0" dirty="0">
+                    <a:latin typeface="CMU Serif Roman" panose="02000603000000000000" pitchFamily="2" charset="0"/>
+                    <a:ea typeface="CMU Serif Roman" panose="02000603000000000000" pitchFamily="2" charset="0"/>
+                    <a:cs typeface="CMU Serif Roman" panose="02000603000000000000" pitchFamily="2" charset="0"/>
+                  </a:rPr>
                   <a:t> “parameter efficient”</a:t>
                 </a:r>
                 <a:r>
-                  <a:rPr lang="en-US" dirty="0"/>
+                  <a:rPr lang="en-US" dirty="0">
+                    <a:latin typeface="CMU Serif Roman" panose="02000603000000000000" pitchFamily="2" charset="0"/>
+                    <a:ea typeface="CMU Serif Roman" panose="02000603000000000000" pitchFamily="2" charset="0"/>
+                    <a:cs typeface="CMU Serif Roman" panose="02000603000000000000" pitchFamily="2" charset="0"/>
+                  </a:rPr>
                   <a:t>, i.e. better than the </a:t>
                 </a:r>
                 <a14:m>
@@ -8222,7 +8469,11 @@
                   </m:oMath>
                 </a14:m>
                 <a:r>
-                  <a:rPr lang="en-GB" b="0" dirty="0"/>
+                  <a:rPr lang="en-GB" b="0" dirty="0">
+                    <a:latin typeface="CMU Serif Roman" panose="02000603000000000000" pitchFamily="2" charset="0"/>
+                    <a:ea typeface="CMU Serif Roman" panose="02000603000000000000" pitchFamily="2" charset="0"/>
+                    <a:cs typeface="CMU Serif Roman" panose="02000603000000000000" pitchFamily="2" charset="0"/>
+                  </a:rPr>
                   <a:t>parameters defined in </a:t>
                 </a:r>
                 <a14:m>
@@ -8235,52 +8486,88 @@
                     </m:r>
                   </m:oMath>
                 </a14:m>
-                <a:endParaRPr lang="en-US" dirty="0"/>
+                <a:endParaRPr lang="en-US" dirty="0">
+                  <a:latin typeface="CMU Serif Roman" panose="02000603000000000000" pitchFamily="2" charset="0"/>
+                  <a:ea typeface="CMU Serif Roman" panose="02000603000000000000" pitchFamily="2" charset="0"/>
+                  <a:cs typeface="CMU Serif Roman" panose="02000603000000000000" pitchFamily="2" charset="0"/>
+                </a:endParaRPr>
               </a:p>
               <a:p>
                 <a:pPr marL="0" indent="0">
                   <a:buNone/>
                 </a:pPr>
-                <a:endParaRPr lang="en-US" dirty="0"/>
+                <a:endParaRPr lang="en-US" dirty="0">
+                  <a:latin typeface="CMU Serif Roman" panose="02000603000000000000" pitchFamily="2" charset="0"/>
+                  <a:ea typeface="CMU Serif Roman" panose="02000603000000000000" pitchFamily="2" charset="0"/>
+                  <a:cs typeface="CMU Serif Roman" panose="02000603000000000000" pitchFamily="2" charset="0"/>
+                </a:endParaRPr>
               </a:p>
               <a:p>
                 <a:pPr marL="0" indent="0">
                   <a:buNone/>
                 </a:pPr>
-                <a:endParaRPr lang="en-US" b="0" dirty="0"/>
+                <a:endParaRPr lang="en-US" b="0" dirty="0">
+                  <a:latin typeface="CMU Serif Roman" panose="02000603000000000000" pitchFamily="2" charset="0"/>
+                  <a:ea typeface="CMU Serif Roman" panose="02000603000000000000" pitchFamily="2" charset="0"/>
+                  <a:cs typeface="CMU Serif Roman" panose="02000603000000000000" pitchFamily="2" charset="0"/>
+                </a:endParaRPr>
               </a:p>
               <a:p>
                 <a:pPr marL="0" indent="0">
                   <a:buNone/>
                 </a:pPr>
-                <a:endParaRPr lang="en-US" dirty="0"/>
+                <a:endParaRPr lang="en-US" dirty="0">
+                  <a:latin typeface="CMU Serif Roman" panose="02000603000000000000" pitchFamily="2" charset="0"/>
+                  <a:ea typeface="CMU Serif Roman" panose="02000603000000000000" pitchFamily="2" charset="0"/>
+                  <a:cs typeface="CMU Serif Roman" panose="02000603000000000000" pitchFamily="2" charset="0"/>
+                </a:endParaRPr>
               </a:p>
               <a:p>
                 <a:pPr marL="0" indent="0">
                   <a:buNone/>
                 </a:pPr>
-                <a:endParaRPr lang="en-US" b="0" dirty="0"/>
+                <a:endParaRPr lang="en-US" b="0" dirty="0">
+                  <a:latin typeface="CMU Serif Roman" panose="02000603000000000000" pitchFamily="2" charset="0"/>
+                  <a:ea typeface="CMU Serif Roman" panose="02000603000000000000" pitchFamily="2" charset="0"/>
+                  <a:cs typeface="CMU Serif Roman" panose="02000603000000000000" pitchFamily="2" charset="0"/>
+                </a:endParaRPr>
               </a:p>
               <a:p>
                 <a:pPr marL="0" indent="0">
                   <a:buNone/>
                 </a:pPr>
-                <a:endParaRPr lang="en-US" dirty="0"/>
+                <a:endParaRPr lang="en-US" dirty="0">
+                  <a:latin typeface="CMU Serif Roman" panose="02000603000000000000" pitchFamily="2" charset="0"/>
+                  <a:ea typeface="CMU Serif Roman" panose="02000603000000000000" pitchFamily="2" charset="0"/>
+                  <a:cs typeface="CMU Serif Roman" panose="02000603000000000000" pitchFamily="2" charset="0"/>
+                </a:endParaRPr>
               </a:p>
               <a:p>
                 <a:pPr marL="0" indent="0">
                   <a:buNone/>
                 </a:pPr>
                 <a:r>
-                  <a:rPr lang="en-US" dirty="0"/>
+                  <a:rPr lang="en-US" dirty="0">
+                    <a:latin typeface="CMU Serif Roman" panose="02000603000000000000" pitchFamily="2" charset="0"/>
+                    <a:ea typeface="CMU Serif Roman" panose="02000603000000000000" pitchFamily="2" charset="0"/>
+                    <a:cs typeface="CMU Serif Roman" panose="02000603000000000000" pitchFamily="2" charset="0"/>
+                  </a:rPr>
                   <a:t>But w</a:t>
                 </a:r>
                 <a:r>
-                  <a:rPr lang="en-US" b="0" dirty="0"/>
+                  <a:rPr lang="en-US" b="0" dirty="0">
+                    <a:latin typeface="CMU Serif Roman" panose="02000603000000000000" pitchFamily="2" charset="0"/>
+                    <a:ea typeface="CMU Serif Roman" panose="02000603000000000000" pitchFamily="2" charset="0"/>
+                    <a:cs typeface="CMU Serif Roman" panose="02000603000000000000" pitchFamily="2" charset="0"/>
+                  </a:rPr>
                   <a:t>e can</a:t>
                 </a:r>
                 <a:r>
-                  <a:rPr lang="en-US" dirty="0"/>
+                  <a:rPr lang="en-US" dirty="0">
+                    <a:latin typeface="CMU Serif Roman" panose="02000603000000000000" pitchFamily="2" charset="0"/>
+                    <a:ea typeface="CMU Serif Roman" panose="02000603000000000000" pitchFamily="2" charset="0"/>
+                    <a:cs typeface="CMU Serif Roman" panose="02000603000000000000" pitchFamily="2" charset="0"/>
+                  </a:rPr>
                   <a:t> only add matrices that have the same dimensions, so </a:t>
                 </a:r>
                 <a14:m>
@@ -8303,7 +8590,11 @@
                   </m:oMath>
                 </a14:m>
                 <a:r>
-                  <a:rPr lang="en-GB" b="0" dirty="0"/>
+                  <a:rPr lang="en-GB" b="0" dirty="0">
+                    <a:latin typeface="CMU Serif Roman" panose="02000603000000000000" pitchFamily="2" charset="0"/>
+                    <a:ea typeface="CMU Serif Roman" panose="02000603000000000000" pitchFamily="2" charset="0"/>
+                    <a:cs typeface="CMU Serif Roman" panose="02000603000000000000" pitchFamily="2" charset="0"/>
+                  </a:rPr>
                   <a:t> must also be </a:t>
                 </a:r>
                 <a14:m>
@@ -8329,7 +8620,11 @@
                   </m:oMath>
                 </a14:m>
                 <a:r>
-                  <a:rPr lang="en-GB" b="0" dirty="0"/>
+                  <a:rPr lang="en-GB" b="0" dirty="0">
+                    <a:latin typeface="CMU Serif Roman" panose="02000603000000000000" pitchFamily="2" charset="0"/>
+                    <a:ea typeface="CMU Serif Roman" panose="02000603000000000000" pitchFamily="2" charset="0"/>
+                    <a:cs typeface="CMU Serif Roman" panose="02000603000000000000" pitchFamily="2" charset="0"/>
+                  </a:rPr>
                   <a:t> !</a:t>
                 </a:r>
               </a:p>
@@ -8337,24 +8632,36 @@
                 <a:pPr marL="0" indent="0">
                   <a:buNone/>
                 </a:pPr>
-                <a:endParaRPr lang="en-GB" b="0" dirty="0"/>
+                <a:endParaRPr lang="en-GB" b="0" dirty="0">
+                  <a:latin typeface="CMU Serif Roman" panose="02000603000000000000" pitchFamily="2" charset="0"/>
+                  <a:ea typeface="CMU Serif Roman" panose="02000603000000000000" pitchFamily="2" charset="0"/>
+                  <a:cs typeface="CMU Serif Roman" panose="02000603000000000000" pitchFamily="2" charset="0"/>
+                </a:endParaRPr>
               </a:p>
               <a:p>
                 <a:pPr marL="0" indent="0">
                   <a:buNone/>
                 </a:pPr>
-                <a:endParaRPr lang="en-GB" b="0" dirty="0"/>
+                <a:endParaRPr lang="en-GB" b="0" dirty="0">
+                  <a:latin typeface="CMU Serif Roman" panose="02000603000000000000" pitchFamily="2" charset="0"/>
+                  <a:ea typeface="CMU Serif Roman" panose="02000603000000000000" pitchFamily="2" charset="0"/>
+                  <a:cs typeface="CMU Serif Roman" panose="02000603000000000000" pitchFamily="2" charset="0"/>
+                </a:endParaRPr>
               </a:p>
               <a:p>
                 <a:pPr marL="0" indent="0">
                   <a:buNone/>
                 </a:pPr>
-                <a:endParaRPr lang="en-GB" b="0" dirty="0"/>
+                <a:endParaRPr lang="en-GB" b="0" dirty="0">
+                  <a:latin typeface="CMU Serif Roman" panose="02000603000000000000" pitchFamily="2" charset="0"/>
+                  <a:ea typeface="CMU Serif Roman" panose="02000603000000000000" pitchFamily="2" charset="0"/>
+                  <a:cs typeface="CMU Serif Roman" panose="02000603000000000000" pitchFamily="2" charset="0"/>
+                </a:endParaRPr>
               </a:p>
             </p:txBody>
           </p:sp>
         </mc:Choice>
-        <mc:Fallback xmlns="">
+        <mc:Fallback>
           <p:sp>
             <p:nvSpPr>
               <p:cNvPr id="5" name="Content Placeholder 2">
@@ -8379,7 +8686,7 @@
               <a:blipFill>
                 <a:blip r:embed="rId2"/>
                 <a:stretch>
-                  <a:fillRect l="-1206" t="-2326" b="-3198"/>
+                  <a:fillRect l="-1206" t="-2035" r="-121" b="-3488"/>
                 </a:stretch>
               </a:blipFill>
             </p:spPr>
@@ -8414,7 +8721,7 @@
         </p:nvSpPr>
         <p:spPr>
           <a:xfrm>
-            <a:off x="8740464" y="6158508"/>
+            <a:off x="9480692" y="5793804"/>
             <a:ext cx="3118738" cy="529390"/>
           </a:xfrm>
           <a:prstGeom prst="rect">
@@ -8601,6 +8908,9 @@
                     <a:lumOff val="50000"/>
                   </a:schemeClr>
                 </a:solidFill>
+                <a:latin typeface="CMU Serif Roman" panose="02000603000000000000" pitchFamily="2" charset="0"/>
+                <a:ea typeface="CMU Serif Roman" panose="02000603000000000000" pitchFamily="2" charset="0"/>
+                <a:cs typeface="CMU Serif Roman" panose="02000603000000000000" pitchFamily="2" charset="0"/>
               </a:rPr>
               <a:t>arXiv:2106.09685</a:t>
             </a:r>
@@ -8613,6 +8923,9 @@
                   <a:lumOff val="50000"/>
                 </a:schemeClr>
               </a:solidFill>
+              <a:latin typeface="CMU Serif Roman" panose="02000603000000000000" pitchFamily="2" charset="0"/>
+              <a:ea typeface="CMU Serif Roman" panose="02000603000000000000" pitchFamily="2" charset="0"/>
+              <a:cs typeface="CMU Serif Roman" panose="02000603000000000000" pitchFamily="2" charset="0"/>
             </a:endParaRPr>
           </a:p>
           <a:p>
@@ -8623,6 +8936,9 @@
                   <a:lumOff val="50000"/>
                 </a:schemeClr>
               </a:solidFill>
+              <a:latin typeface="CMU Serif Roman" panose="02000603000000000000" pitchFamily="2" charset="0"/>
+              <a:ea typeface="CMU Serif Roman" panose="02000603000000000000" pitchFamily="2" charset="0"/>
+              <a:cs typeface="CMU Serif Roman" panose="02000603000000000000" pitchFamily="2" charset="0"/>
             </a:endParaRPr>
           </a:p>
         </p:txBody>
@@ -9379,22 +9695,34 @@
           <a:lstStyle/>
           <a:p>
             <a:r>
-              <a:rPr lang="en-US" dirty="0"/>
+              <a:rPr lang="en-US" dirty="0">
+                <a:latin typeface="CMU Serif Roman" panose="02000603000000000000" pitchFamily="2" charset="0"/>
+                <a:ea typeface="CMU Serif Roman" panose="02000603000000000000" pitchFamily="2" charset="0"/>
+                <a:cs typeface="CMU Serif Roman" panose="02000603000000000000" pitchFamily="2" charset="0"/>
+              </a:rPr>
               <a:t>Low Rank Adaptation (</a:t>
             </a:r>
             <a:r>
-              <a:rPr lang="en-US" dirty="0" err="1"/>
+              <a:rPr lang="en-US" dirty="0" err="1">
+                <a:latin typeface="CMU Serif Roman" panose="02000603000000000000" pitchFamily="2" charset="0"/>
+                <a:ea typeface="CMU Serif Roman" panose="02000603000000000000" pitchFamily="2" charset="0"/>
+                <a:cs typeface="CMU Serif Roman" panose="02000603000000000000" pitchFamily="2" charset="0"/>
+              </a:rPr>
               <a:t>LoRA</a:t>
             </a:r>
             <a:r>
-              <a:rPr lang="en-US" dirty="0"/>
+              <a:rPr lang="en-US" dirty="0">
+                <a:latin typeface="CMU Serif Roman" panose="02000603000000000000" pitchFamily="2" charset="0"/>
+                <a:ea typeface="CMU Serif Roman" panose="02000603000000000000" pitchFamily="2" charset="0"/>
+                <a:cs typeface="CMU Serif Roman" panose="02000603000000000000" pitchFamily="2" charset="0"/>
+              </a:rPr>
               <a:t>)</a:t>
             </a:r>
           </a:p>
         </p:txBody>
       </p:sp>
-      <mc:AlternateContent xmlns:mc="http://schemas.openxmlformats.org/markup-compatibility/2006" xmlns:a14="http://schemas.microsoft.com/office/drawing/2010/main">
-        <mc:Choice Requires="a14">
+      <mc:AlternateContent xmlns:mc="http://schemas.openxmlformats.org/markup-compatibility/2006">
+        <mc:Choice xmlns:a14="http://schemas.microsoft.com/office/drawing/2010/main" Requires="a14">
           <p:sp>
             <p:nvSpPr>
               <p:cNvPr id="5" name="Content Placeholder 2">
@@ -9427,11 +9755,19 @@
                   <a:buNone/>
                 </a:pPr>
                 <a:r>
-                  <a:rPr lang="en-US" b="1" dirty="0"/>
+                  <a:rPr lang="en-US" b="1" dirty="0">
+                    <a:latin typeface="CMU SERIF ROMAN" panose="02000603000000000000" pitchFamily="2" charset="0"/>
+                    <a:ea typeface="CMU SERIF ROMAN" panose="02000603000000000000" pitchFamily="2" charset="0"/>
+                    <a:cs typeface="CMU SERIF ROMAN" panose="02000603000000000000" pitchFamily="2" charset="0"/>
+                  </a:rPr>
                   <a:t>The solution: </a:t>
                 </a:r>
                 <a:r>
-                  <a:rPr lang="en-US" dirty="0"/>
+                  <a:rPr lang="en-US" dirty="0">
+                    <a:latin typeface="CMU Serif Roman" panose="02000603000000000000" pitchFamily="2" charset="0"/>
+                    <a:ea typeface="CMU Serif Roman" panose="02000603000000000000" pitchFamily="2" charset="0"/>
+                    <a:cs typeface="CMU Serif Roman" panose="02000603000000000000" pitchFamily="2" charset="0"/>
+                  </a:rPr>
                   <a:t>express the adapter </a:t>
                 </a:r>
                 <a14:m>
@@ -9454,7 +9790,11 @@
                   </m:oMath>
                 </a14:m>
                 <a:r>
-                  <a:rPr lang="en-GB" b="0" dirty="0"/>
+                  <a:rPr lang="en-GB" b="0" dirty="0">
+                    <a:latin typeface="CMU Serif Roman" panose="02000603000000000000" pitchFamily="2" charset="0"/>
+                    <a:ea typeface="CMU Serif Roman" panose="02000603000000000000" pitchFamily="2" charset="0"/>
+                    <a:cs typeface="CMU Serif Roman" panose="02000603000000000000" pitchFamily="2" charset="0"/>
+                  </a:rPr>
                   <a:t> as a product of low rank matrices</a:t>
                 </a:r>
               </a:p>
@@ -9462,30 +9802,46 @@
                 <a:pPr marL="0" indent="0">
                   <a:buNone/>
                 </a:pPr>
-                <a:endParaRPr lang="en-US" dirty="0"/>
+                <a:endParaRPr lang="en-US" dirty="0">
+                  <a:latin typeface="CMU Serif Roman" panose="02000603000000000000" pitchFamily="2" charset="0"/>
+                  <a:ea typeface="CMU Serif Roman" panose="02000603000000000000" pitchFamily="2" charset="0"/>
+                  <a:cs typeface="CMU Serif Roman" panose="02000603000000000000" pitchFamily="2" charset="0"/>
+                </a:endParaRPr>
               </a:p>
               <a:p>
                 <a:pPr marL="0" indent="0">
                   <a:buNone/>
                 </a:pPr>
-                <a:endParaRPr lang="en-GB" b="0" dirty="0"/>
+                <a:endParaRPr lang="en-GB" b="0" dirty="0">
+                  <a:latin typeface="CMU Serif Roman" panose="02000603000000000000" pitchFamily="2" charset="0"/>
+                  <a:ea typeface="CMU Serif Roman" panose="02000603000000000000" pitchFamily="2" charset="0"/>
+                  <a:cs typeface="CMU Serif Roman" panose="02000603000000000000" pitchFamily="2" charset="0"/>
+                </a:endParaRPr>
               </a:p>
               <a:p>
                 <a:pPr marL="0" indent="0">
                   <a:buNone/>
                 </a:pPr>
-                <a:endParaRPr lang="en-GB" b="0" dirty="0"/>
+                <a:endParaRPr lang="en-GB" b="0" dirty="0">
+                  <a:latin typeface="CMU Serif Roman" panose="02000603000000000000" pitchFamily="2" charset="0"/>
+                  <a:ea typeface="CMU Serif Roman" panose="02000603000000000000" pitchFamily="2" charset="0"/>
+                  <a:cs typeface="CMU Serif Roman" panose="02000603000000000000" pitchFamily="2" charset="0"/>
+                </a:endParaRPr>
               </a:p>
               <a:p>
                 <a:pPr marL="0" indent="0">
                   <a:buNone/>
                 </a:pPr>
-                <a:endParaRPr lang="en-GB" b="0" dirty="0"/>
+                <a:endParaRPr lang="en-GB" b="0" dirty="0">
+                  <a:latin typeface="CMU Serif Roman" panose="02000603000000000000" pitchFamily="2" charset="0"/>
+                  <a:ea typeface="CMU Serif Roman" panose="02000603000000000000" pitchFamily="2" charset="0"/>
+                  <a:cs typeface="CMU Serif Roman" panose="02000603000000000000" pitchFamily="2" charset="0"/>
+                </a:endParaRPr>
               </a:p>
             </p:txBody>
           </p:sp>
         </mc:Choice>
-        <mc:Fallback xmlns="">
+        <mc:Fallback>
           <p:sp>
             <p:nvSpPr>
               <p:cNvPr id="5" name="Content Placeholder 2">
@@ -9510,7 +9866,7 @@
               <a:blipFill>
                 <a:blip r:embed="rId2"/>
                 <a:stretch>
-                  <a:fillRect l="-1206" t="-2326"/>
+                  <a:fillRect l="-1206" t="-2035"/>
                 </a:stretch>
               </a:blipFill>
             </p:spPr>
@@ -9529,235 +9885,6 @@
           </p:sp>
         </mc:Fallback>
       </mc:AlternateContent>
-      <p:sp>
-        <p:nvSpPr>
-          <p:cNvPr id="6" name="Content Placeholder 2">
-            <a:extLst>
-              <a:ext uri="{FF2B5EF4-FFF2-40B4-BE49-F238E27FC236}">
-                <a16:creationId xmlns:a16="http://schemas.microsoft.com/office/drawing/2014/main" id="{646C9CEF-DE1B-01F4-EBD7-418B84FCA546}"/>
-              </a:ext>
-            </a:extLst>
-          </p:cNvPr>
-          <p:cNvSpPr txBox="1">
-            <a:spLocks/>
-          </p:cNvSpPr>
-          <p:nvPr/>
-        </p:nvSpPr>
-        <p:spPr>
-          <a:xfrm>
-            <a:off x="8740464" y="6158508"/>
-            <a:ext cx="3118738" cy="529390"/>
-          </a:xfrm>
-          <a:prstGeom prst="rect">
-            <a:avLst/>
-          </a:prstGeom>
-        </p:spPr>
-        <p:txBody>
-          <a:bodyPr vert="horz" lIns="91440" tIns="45720" rIns="91440" bIns="45720" rtlCol="0">
-            <a:normAutofit/>
-          </a:bodyPr>
-          <a:lstStyle>
-            <a:lvl1pPr marL="228600" indent="-228600" algn="l" defTabSz="914400" rtl="0" eaLnBrk="1" latinLnBrk="0" hangingPunct="1">
-              <a:lnSpc>
-                <a:spcPct val="90000"/>
-              </a:lnSpc>
-              <a:spcBef>
-                <a:spcPts val="1000"/>
-              </a:spcBef>
-              <a:buFont typeface="Arial" panose="020B0604020202020204" pitchFamily="34" charset="0"/>
-              <a:buChar char="•"/>
-              <a:defRPr sz="2800" kern="1200">
-                <a:solidFill>
-                  <a:schemeClr val="tx1"/>
-                </a:solidFill>
-                <a:latin typeface="+mn-lt"/>
-                <a:ea typeface="+mn-ea"/>
-                <a:cs typeface="+mn-cs"/>
-              </a:defRPr>
-            </a:lvl1pPr>
-            <a:lvl2pPr marL="685800" indent="-228600" algn="l" defTabSz="914400" rtl="0" eaLnBrk="1" latinLnBrk="0" hangingPunct="1">
-              <a:lnSpc>
-                <a:spcPct val="90000"/>
-              </a:lnSpc>
-              <a:spcBef>
-                <a:spcPts val="500"/>
-              </a:spcBef>
-              <a:buFont typeface="Arial" panose="020B0604020202020204" pitchFamily="34" charset="0"/>
-              <a:buChar char="•"/>
-              <a:defRPr sz="2400" kern="1200">
-                <a:solidFill>
-                  <a:schemeClr val="tx1"/>
-                </a:solidFill>
-                <a:latin typeface="+mn-lt"/>
-                <a:ea typeface="+mn-ea"/>
-                <a:cs typeface="+mn-cs"/>
-              </a:defRPr>
-            </a:lvl2pPr>
-            <a:lvl3pPr marL="1143000" indent="-228600" algn="l" defTabSz="914400" rtl="0" eaLnBrk="1" latinLnBrk="0" hangingPunct="1">
-              <a:lnSpc>
-                <a:spcPct val="90000"/>
-              </a:lnSpc>
-              <a:spcBef>
-                <a:spcPts val="500"/>
-              </a:spcBef>
-              <a:buFont typeface="Arial" panose="020B0604020202020204" pitchFamily="34" charset="0"/>
-              <a:buChar char="•"/>
-              <a:defRPr sz="2000" kern="1200">
-                <a:solidFill>
-                  <a:schemeClr val="tx1"/>
-                </a:solidFill>
-                <a:latin typeface="+mn-lt"/>
-                <a:ea typeface="+mn-ea"/>
-                <a:cs typeface="+mn-cs"/>
-              </a:defRPr>
-            </a:lvl3pPr>
-            <a:lvl4pPr marL="1600200" indent="-228600" algn="l" defTabSz="914400" rtl="0" eaLnBrk="1" latinLnBrk="0" hangingPunct="1">
-              <a:lnSpc>
-                <a:spcPct val="90000"/>
-              </a:lnSpc>
-              <a:spcBef>
-                <a:spcPts val="500"/>
-              </a:spcBef>
-              <a:buFont typeface="Arial" panose="020B0604020202020204" pitchFamily="34" charset="0"/>
-              <a:buChar char="•"/>
-              <a:defRPr sz="1800" kern="1200">
-                <a:solidFill>
-                  <a:schemeClr val="tx1"/>
-                </a:solidFill>
-                <a:latin typeface="+mn-lt"/>
-                <a:ea typeface="+mn-ea"/>
-                <a:cs typeface="+mn-cs"/>
-              </a:defRPr>
-            </a:lvl4pPr>
-            <a:lvl5pPr marL="2057400" indent="-228600" algn="l" defTabSz="914400" rtl="0" eaLnBrk="1" latinLnBrk="0" hangingPunct="1">
-              <a:lnSpc>
-                <a:spcPct val="90000"/>
-              </a:lnSpc>
-              <a:spcBef>
-                <a:spcPts val="500"/>
-              </a:spcBef>
-              <a:buFont typeface="Arial" panose="020B0604020202020204" pitchFamily="34" charset="0"/>
-              <a:buChar char="•"/>
-              <a:defRPr sz="1800" kern="1200">
-                <a:solidFill>
-                  <a:schemeClr val="tx1"/>
-                </a:solidFill>
-                <a:latin typeface="+mn-lt"/>
-                <a:ea typeface="+mn-ea"/>
-                <a:cs typeface="+mn-cs"/>
-              </a:defRPr>
-            </a:lvl5pPr>
-            <a:lvl6pPr marL="2514600" indent="-228600" algn="l" defTabSz="914400" rtl="0" eaLnBrk="1" latinLnBrk="0" hangingPunct="1">
-              <a:lnSpc>
-                <a:spcPct val="90000"/>
-              </a:lnSpc>
-              <a:spcBef>
-                <a:spcPts val="500"/>
-              </a:spcBef>
-              <a:buFont typeface="Arial" panose="020B0604020202020204" pitchFamily="34" charset="0"/>
-              <a:buChar char="•"/>
-              <a:defRPr sz="1800" kern="1200">
-                <a:solidFill>
-                  <a:schemeClr val="tx1"/>
-                </a:solidFill>
-                <a:latin typeface="+mn-lt"/>
-                <a:ea typeface="+mn-ea"/>
-                <a:cs typeface="+mn-cs"/>
-              </a:defRPr>
-            </a:lvl6pPr>
-            <a:lvl7pPr marL="2971800" indent="-228600" algn="l" defTabSz="914400" rtl="0" eaLnBrk="1" latinLnBrk="0" hangingPunct="1">
-              <a:lnSpc>
-                <a:spcPct val="90000"/>
-              </a:lnSpc>
-              <a:spcBef>
-                <a:spcPts val="500"/>
-              </a:spcBef>
-              <a:buFont typeface="Arial" panose="020B0604020202020204" pitchFamily="34" charset="0"/>
-              <a:buChar char="•"/>
-              <a:defRPr sz="1800" kern="1200">
-                <a:solidFill>
-                  <a:schemeClr val="tx1"/>
-                </a:solidFill>
-                <a:latin typeface="+mn-lt"/>
-                <a:ea typeface="+mn-ea"/>
-                <a:cs typeface="+mn-cs"/>
-              </a:defRPr>
-            </a:lvl7pPr>
-            <a:lvl8pPr marL="3429000" indent="-228600" algn="l" defTabSz="914400" rtl="0" eaLnBrk="1" latinLnBrk="0" hangingPunct="1">
-              <a:lnSpc>
-                <a:spcPct val="90000"/>
-              </a:lnSpc>
-              <a:spcBef>
-                <a:spcPts val="500"/>
-              </a:spcBef>
-              <a:buFont typeface="Arial" panose="020B0604020202020204" pitchFamily="34" charset="0"/>
-              <a:buChar char="•"/>
-              <a:defRPr sz="1800" kern="1200">
-                <a:solidFill>
-                  <a:schemeClr val="tx1"/>
-                </a:solidFill>
-                <a:latin typeface="+mn-lt"/>
-                <a:ea typeface="+mn-ea"/>
-                <a:cs typeface="+mn-cs"/>
-              </a:defRPr>
-            </a:lvl8pPr>
-            <a:lvl9pPr marL="3886200" indent="-228600" algn="l" defTabSz="914400" rtl="0" eaLnBrk="1" latinLnBrk="0" hangingPunct="1">
-              <a:lnSpc>
-                <a:spcPct val="90000"/>
-              </a:lnSpc>
-              <a:spcBef>
-                <a:spcPts val="500"/>
-              </a:spcBef>
-              <a:buFont typeface="Arial" panose="020B0604020202020204" pitchFamily="34" charset="0"/>
-              <a:buChar char="•"/>
-              <a:defRPr sz="1800" kern="1200">
-                <a:solidFill>
-                  <a:schemeClr val="tx1"/>
-                </a:solidFill>
-                <a:latin typeface="+mn-lt"/>
-                <a:ea typeface="+mn-ea"/>
-                <a:cs typeface="+mn-cs"/>
-              </a:defRPr>
-            </a:lvl9pPr>
-          </a:lstStyle>
-          <a:p>
-            <a:pPr marL="0" indent="0">
-              <a:buNone/>
-            </a:pPr>
-            <a:r>
-              <a:rPr lang="en-GB" sz="2400" dirty="0">
-                <a:solidFill>
-                  <a:schemeClr val="tx1">
-                    <a:lumMod val="50000"/>
-                    <a:lumOff val="50000"/>
-                  </a:schemeClr>
-                </a:solidFill>
-              </a:rPr>
-              <a:t>arXiv:2106.09685</a:t>
-            </a:r>
-          </a:p>
-          <a:p>
-            <a:endParaRPr lang="en-US" sz="2400" dirty="0">
-              <a:solidFill>
-                <a:schemeClr val="tx1">
-                  <a:lumMod val="50000"/>
-                  <a:lumOff val="50000"/>
-                </a:schemeClr>
-              </a:solidFill>
-            </a:endParaRPr>
-          </a:p>
-          <a:p>
-            <a:endParaRPr lang="en-US" sz="2400" dirty="0">
-              <a:solidFill>
-                <a:schemeClr val="tx1">
-                  <a:lumMod val="50000"/>
-                  <a:lumOff val="50000"/>
-                </a:schemeClr>
-              </a:solidFill>
-            </a:endParaRPr>
-          </a:p>
-        </p:txBody>
-      </p:sp>
       <mc:AlternateContent xmlns:mc="http://schemas.openxmlformats.org/markup-compatibility/2006" xmlns:a14="http://schemas.microsoft.com/office/drawing/2010/main">
         <mc:Choice Requires="a14">
           <p:sp>
@@ -10834,8 +10961,8 @@
           </a:p>
         </p:txBody>
       </p:sp>
-      <mc:AlternateContent xmlns:mc="http://schemas.openxmlformats.org/markup-compatibility/2006" xmlns:a14="http://schemas.microsoft.com/office/drawing/2010/main">
-        <mc:Choice Requires="a14">
+      <mc:AlternateContent xmlns:mc="http://schemas.openxmlformats.org/markup-compatibility/2006">
+        <mc:Choice xmlns:a14="http://schemas.microsoft.com/office/drawing/2010/main" Requires="a14">
           <p:sp>
             <p:nvSpPr>
               <p:cNvPr id="29" name="TextBox 28">
@@ -10850,8 +10977,8 @@
             </p:nvSpPr>
             <p:spPr>
               <a:xfrm>
-                <a:off x="1020337" y="6014893"/>
-                <a:ext cx="6099716" cy="523220"/>
+                <a:off x="396138" y="5659097"/>
+                <a:ext cx="6099716" cy="400110"/>
               </a:xfrm>
               <a:prstGeom prst="rect">
                 <a:avLst/>
@@ -10868,69 +10995,77 @@
                   <a:buNone/>
                 </a:pPr>
                 <a:r>
-                  <a:rPr lang="en-GB" sz="2800" b="0" dirty="0"/>
+                  <a:rPr lang="en-GB" sz="2000" b="1" dirty="0">
+                    <a:latin typeface="CMU SERIF ROMAN" panose="02000603000000000000" pitchFamily="2" charset="0"/>
+                    <a:ea typeface="CMU SERIF ROMAN" panose="02000603000000000000" pitchFamily="2" charset="0"/>
+                    <a:cs typeface="CMU SERIF ROMAN" panose="02000603000000000000" pitchFamily="2" charset="0"/>
+                  </a:rPr>
                   <a:t>So, that’s </a:t>
                 </a:r>
                 <a14:m>
                   <m:oMath xmlns:m="http://schemas.openxmlformats.org/officeDocument/2006/math">
                     <m:r>
-                      <a:rPr lang="en-GB" sz="2800" b="0" i="1" smtClean="0">
+                      <a:rPr lang="en-GB" sz="2000" b="1" i="1" smtClean="0">
                         <a:latin typeface="Cambria Math" panose="02040503050406030204" pitchFamily="18" charset="0"/>
                       </a:rPr>
-                      <m:t>𝑟</m:t>
+                      <m:t>𝒓</m:t>
                     </m:r>
                     <m:d>
                       <m:dPr>
                         <m:ctrlPr>
-                          <a:rPr lang="en-GB" sz="2800" b="0" i="1" smtClean="0">
+                          <a:rPr lang="en-GB" sz="2000" b="1" i="1" smtClean="0">
                             <a:latin typeface="Cambria Math" panose="02040503050406030204" pitchFamily="18" charset="0"/>
                           </a:rPr>
                         </m:ctrlPr>
                       </m:dPr>
                       <m:e>
                         <m:r>
-                          <a:rPr lang="en-GB" sz="2800" b="0" i="1" smtClean="0">
+                          <a:rPr lang="en-GB" sz="2000" b="1" i="1" smtClean="0">
                             <a:latin typeface="Cambria Math" panose="02040503050406030204" pitchFamily="18" charset="0"/>
                           </a:rPr>
-                          <m:t>𝑛</m:t>
+                          <m:t>𝒏</m:t>
                         </m:r>
                         <m:r>
-                          <a:rPr lang="en-GB" sz="2800" b="0" i="1" smtClean="0">
+                          <a:rPr lang="en-GB" sz="2000" b="1" i="1" smtClean="0">
                             <a:latin typeface="Cambria Math" panose="02040503050406030204" pitchFamily="18" charset="0"/>
                           </a:rPr>
                           <m:t>+</m:t>
                         </m:r>
                         <m:r>
-                          <a:rPr lang="en-GB" sz="2800" b="0" i="1" smtClean="0">
+                          <a:rPr lang="en-GB" sz="2000" b="1" i="1" smtClean="0">
                             <a:latin typeface="Cambria Math" panose="02040503050406030204" pitchFamily="18" charset="0"/>
                           </a:rPr>
-                          <m:t>𝑚</m:t>
+                          <m:t>𝒎</m:t>
                         </m:r>
                       </m:e>
                     </m:d>
                     <m:r>
-                      <a:rPr lang="en-GB" sz="2800" b="0" i="1" smtClean="0">
+                      <a:rPr lang="en-GB" sz="2000" b="1" i="1" smtClean="0">
                         <a:latin typeface="Cambria Math" panose="02040503050406030204" pitchFamily="18" charset="0"/>
                       </a:rPr>
                       <m:t>≪</m:t>
                     </m:r>
                     <m:r>
-                      <a:rPr lang="en-GB" sz="2800" b="0" i="1" smtClean="0">
+                      <a:rPr lang="en-GB" sz="2000" b="1" i="1" smtClean="0">
                         <a:latin typeface="Cambria Math" panose="02040503050406030204" pitchFamily="18" charset="0"/>
                       </a:rPr>
-                      <m:t>𝑛𝑚</m:t>
+                      <m:t>𝒏𝒎</m:t>
                     </m:r>
                   </m:oMath>
                 </a14:m>
                 <a:r>
-                  <a:rPr lang="en-GB" sz="2800" b="0" dirty="0"/>
+                  <a:rPr lang="en-GB" sz="2000" b="1" dirty="0">
+                    <a:latin typeface="CMU SERIF ROMAN" panose="02000603000000000000" pitchFamily="2" charset="0"/>
+                    <a:ea typeface="CMU SERIF ROMAN" panose="02000603000000000000" pitchFamily="2" charset="0"/>
+                    <a:cs typeface="CMU SERIF ROMAN" panose="02000603000000000000" pitchFamily="2" charset="0"/>
+                  </a:rPr>
                   <a:t> parameters!</a:t>
                 </a:r>
               </a:p>
             </p:txBody>
           </p:sp>
         </mc:Choice>
-        <mc:Fallback xmlns="">
+        <mc:Fallback>
           <p:sp>
             <p:nvSpPr>
               <p:cNvPr id="29" name="TextBox 28">
@@ -10947,8 +11082,8 @@
             </p:nvSpPr>
             <p:spPr>
               <a:xfrm>
-                <a:off x="1020337" y="6014893"/>
-                <a:ext cx="6099716" cy="523220"/>
+                <a:off x="396138" y="5659097"/>
+                <a:ext cx="6099716" cy="400110"/>
               </a:xfrm>
               <a:prstGeom prst="rect">
                 <a:avLst/>
@@ -10956,7 +11091,7 @@
               <a:blipFill>
                 <a:blip r:embed="rId8"/>
                 <a:stretch>
-                  <a:fillRect l="-2079" t="-11628" r="-1247" b="-30233"/>
+                  <a:fillRect l="-1247" t="-3030" b="-27273"/>
                 </a:stretch>
               </a:blipFill>
             </p:spPr>
@@ -10975,6 +11110,244 @@
           </p:sp>
         </mc:Fallback>
       </mc:AlternateContent>
+      <p:sp>
+        <p:nvSpPr>
+          <p:cNvPr id="2" name="Content Placeholder 2">
+            <a:extLst>
+              <a:ext uri="{FF2B5EF4-FFF2-40B4-BE49-F238E27FC236}">
+                <a16:creationId xmlns:a16="http://schemas.microsoft.com/office/drawing/2014/main" id="{6FD50721-403D-3706-C682-365B8DD07B22}"/>
+              </a:ext>
+            </a:extLst>
+          </p:cNvPr>
+          <p:cNvSpPr txBox="1">
+            <a:spLocks/>
+          </p:cNvSpPr>
+          <p:nvPr/>
+        </p:nvSpPr>
+        <p:spPr>
+          <a:xfrm>
+            <a:off x="9480692" y="5793804"/>
+            <a:ext cx="3118738" cy="529390"/>
+          </a:xfrm>
+          <a:prstGeom prst="rect">
+            <a:avLst/>
+          </a:prstGeom>
+        </p:spPr>
+        <p:txBody>
+          <a:bodyPr vert="horz" lIns="91440" tIns="45720" rIns="91440" bIns="45720" rtlCol="0">
+            <a:normAutofit/>
+          </a:bodyPr>
+          <a:lstStyle>
+            <a:lvl1pPr marL="228600" indent="-228600" algn="l" defTabSz="914400" rtl="0" eaLnBrk="1" latinLnBrk="0" hangingPunct="1">
+              <a:lnSpc>
+                <a:spcPct val="90000"/>
+              </a:lnSpc>
+              <a:spcBef>
+                <a:spcPts val="1000"/>
+              </a:spcBef>
+              <a:buFont typeface="Arial" panose="020B0604020202020204" pitchFamily="34" charset="0"/>
+              <a:buChar char="•"/>
+              <a:defRPr sz="2800" kern="1200">
+                <a:solidFill>
+                  <a:schemeClr val="tx1"/>
+                </a:solidFill>
+                <a:latin typeface="+mn-lt"/>
+                <a:ea typeface="+mn-ea"/>
+                <a:cs typeface="+mn-cs"/>
+              </a:defRPr>
+            </a:lvl1pPr>
+            <a:lvl2pPr marL="685800" indent="-228600" algn="l" defTabSz="914400" rtl="0" eaLnBrk="1" latinLnBrk="0" hangingPunct="1">
+              <a:lnSpc>
+                <a:spcPct val="90000"/>
+              </a:lnSpc>
+              <a:spcBef>
+                <a:spcPts val="500"/>
+              </a:spcBef>
+              <a:buFont typeface="Arial" panose="020B0604020202020204" pitchFamily="34" charset="0"/>
+              <a:buChar char="•"/>
+              <a:defRPr sz="2400" kern="1200">
+                <a:solidFill>
+                  <a:schemeClr val="tx1"/>
+                </a:solidFill>
+                <a:latin typeface="+mn-lt"/>
+                <a:ea typeface="+mn-ea"/>
+                <a:cs typeface="+mn-cs"/>
+              </a:defRPr>
+            </a:lvl2pPr>
+            <a:lvl3pPr marL="1143000" indent="-228600" algn="l" defTabSz="914400" rtl="0" eaLnBrk="1" latinLnBrk="0" hangingPunct="1">
+              <a:lnSpc>
+                <a:spcPct val="90000"/>
+              </a:lnSpc>
+              <a:spcBef>
+                <a:spcPts val="500"/>
+              </a:spcBef>
+              <a:buFont typeface="Arial" panose="020B0604020202020204" pitchFamily="34" charset="0"/>
+              <a:buChar char="•"/>
+              <a:defRPr sz="2000" kern="1200">
+                <a:solidFill>
+                  <a:schemeClr val="tx1"/>
+                </a:solidFill>
+                <a:latin typeface="+mn-lt"/>
+                <a:ea typeface="+mn-ea"/>
+                <a:cs typeface="+mn-cs"/>
+              </a:defRPr>
+            </a:lvl3pPr>
+            <a:lvl4pPr marL="1600200" indent="-228600" algn="l" defTabSz="914400" rtl="0" eaLnBrk="1" latinLnBrk="0" hangingPunct="1">
+              <a:lnSpc>
+                <a:spcPct val="90000"/>
+              </a:lnSpc>
+              <a:spcBef>
+                <a:spcPts val="500"/>
+              </a:spcBef>
+              <a:buFont typeface="Arial" panose="020B0604020202020204" pitchFamily="34" charset="0"/>
+              <a:buChar char="•"/>
+              <a:defRPr sz="1800" kern="1200">
+                <a:solidFill>
+                  <a:schemeClr val="tx1"/>
+                </a:solidFill>
+                <a:latin typeface="+mn-lt"/>
+                <a:ea typeface="+mn-ea"/>
+                <a:cs typeface="+mn-cs"/>
+              </a:defRPr>
+            </a:lvl4pPr>
+            <a:lvl5pPr marL="2057400" indent="-228600" algn="l" defTabSz="914400" rtl="0" eaLnBrk="1" latinLnBrk="0" hangingPunct="1">
+              <a:lnSpc>
+                <a:spcPct val="90000"/>
+              </a:lnSpc>
+              <a:spcBef>
+                <a:spcPts val="500"/>
+              </a:spcBef>
+              <a:buFont typeface="Arial" panose="020B0604020202020204" pitchFamily="34" charset="0"/>
+              <a:buChar char="•"/>
+              <a:defRPr sz="1800" kern="1200">
+                <a:solidFill>
+                  <a:schemeClr val="tx1"/>
+                </a:solidFill>
+                <a:latin typeface="+mn-lt"/>
+                <a:ea typeface="+mn-ea"/>
+                <a:cs typeface="+mn-cs"/>
+              </a:defRPr>
+            </a:lvl5pPr>
+            <a:lvl6pPr marL="2514600" indent="-228600" algn="l" defTabSz="914400" rtl="0" eaLnBrk="1" latinLnBrk="0" hangingPunct="1">
+              <a:lnSpc>
+                <a:spcPct val="90000"/>
+              </a:lnSpc>
+              <a:spcBef>
+                <a:spcPts val="500"/>
+              </a:spcBef>
+              <a:buFont typeface="Arial" panose="020B0604020202020204" pitchFamily="34" charset="0"/>
+              <a:buChar char="•"/>
+              <a:defRPr sz="1800" kern="1200">
+                <a:solidFill>
+                  <a:schemeClr val="tx1"/>
+                </a:solidFill>
+                <a:latin typeface="+mn-lt"/>
+                <a:ea typeface="+mn-ea"/>
+                <a:cs typeface="+mn-cs"/>
+              </a:defRPr>
+            </a:lvl6pPr>
+            <a:lvl7pPr marL="2971800" indent="-228600" algn="l" defTabSz="914400" rtl="0" eaLnBrk="1" latinLnBrk="0" hangingPunct="1">
+              <a:lnSpc>
+                <a:spcPct val="90000"/>
+              </a:lnSpc>
+              <a:spcBef>
+                <a:spcPts val="500"/>
+              </a:spcBef>
+              <a:buFont typeface="Arial" panose="020B0604020202020204" pitchFamily="34" charset="0"/>
+              <a:buChar char="•"/>
+              <a:defRPr sz="1800" kern="1200">
+                <a:solidFill>
+                  <a:schemeClr val="tx1"/>
+                </a:solidFill>
+                <a:latin typeface="+mn-lt"/>
+                <a:ea typeface="+mn-ea"/>
+                <a:cs typeface="+mn-cs"/>
+              </a:defRPr>
+            </a:lvl7pPr>
+            <a:lvl8pPr marL="3429000" indent="-228600" algn="l" defTabSz="914400" rtl="0" eaLnBrk="1" latinLnBrk="0" hangingPunct="1">
+              <a:lnSpc>
+                <a:spcPct val="90000"/>
+              </a:lnSpc>
+              <a:spcBef>
+                <a:spcPts val="500"/>
+              </a:spcBef>
+              <a:buFont typeface="Arial" panose="020B0604020202020204" pitchFamily="34" charset="0"/>
+              <a:buChar char="•"/>
+              <a:defRPr sz="1800" kern="1200">
+                <a:solidFill>
+                  <a:schemeClr val="tx1"/>
+                </a:solidFill>
+                <a:latin typeface="+mn-lt"/>
+                <a:ea typeface="+mn-ea"/>
+                <a:cs typeface="+mn-cs"/>
+              </a:defRPr>
+            </a:lvl8pPr>
+            <a:lvl9pPr marL="3886200" indent="-228600" algn="l" defTabSz="914400" rtl="0" eaLnBrk="1" latinLnBrk="0" hangingPunct="1">
+              <a:lnSpc>
+                <a:spcPct val="90000"/>
+              </a:lnSpc>
+              <a:spcBef>
+                <a:spcPts val="500"/>
+              </a:spcBef>
+              <a:buFont typeface="Arial" panose="020B0604020202020204" pitchFamily="34" charset="0"/>
+              <a:buChar char="•"/>
+              <a:defRPr sz="1800" kern="1200">
+                <a:solidFill>
+                  <a:schemeClr val="tx1"/>
+                </a:solidFill>
+                <a:latin typeface="+mn-lt"/>
+                <a:ea typeface="+mn-ea"/>
+                <a:cs typeface="+mn-cs"/>
+              </a:defRPr>
+            </a:lvl9pPr>
+          </a:lstStyle>
+          <a:p>
+            <a:pPr marL="0" indent="0">
+              <a:buNone/>
+            </a:pPr>
+            <a:r>
+              <a:rPr lang="en-GB" sz="2400" dirty="0">
+                <a:solidFill>
+                  <a:schemeClr val="tx1">
+                    <a:lumMod val="50000"/>
+                    <a:lumOff val="50000"/>
+                  </a:schemeClr>
+                </a:solidFill>
+                <a:latin typeface="CMU Serif Roman" panose="02000603000000000000" pitchFamily="2" charset="0"/>
+                <a:ea typeface="CMU Serif Roman" panose="02000603000000000000" pitchFamily="2" charset="0"/>
+                <a:cs typeface="CMU Serif Roman" panose="02000603000000000000" pitchFamily="2" charset="0"/>
+              </a:rPr>
+              <a:t>arXiv:2106.09685</a:t>
+            </a:r>
+          </a:p>
+          <a:p>
+            <a:endParaRPr lang="en-US" sz="2400" dirty="0">
+              <a:solidFill>
+                <a:schemeClr val="tx1">
+                  <a:lumMod val="50000"/>
+                  <a:lumOff val="50000"/>
+                </a:schemeClr>
+              </a:solidFill>
+              <a:latin typeface="CMU Serif Roman" panose="02000603000000000000" pitchFamily="2" charset="0"/>
+              <a:ea typeface="CMU Serif Roman" panose="02000603000000000000" pitchFamily="2" charset="0"/>
+              <a:cs typeface="CMU Serif Roman" panose="02000603000000000000" pitchFamily="2" charset="0"/>
+            </a:endParaRPr>
+          </a:p>
+          <a:p>
+            <a:endParaRPr lang="en-US" sz="2400" dirty="0">
+              <a:solidFill>
+                <a:schemeClr val="tx1">
+                  <a:lumMod val="50000"/>
+                  <a:lumOff val="50000"/>
+                </a:schemeClr>
+              </a:solidFill>
+              <a:latin typeface="CMU Serif Roman" panose="02000603000000000000" pitchFamily="2" charset="0"/>
+              <a:ea typeface="CMU Serif Roman" panose="02000603000000000000" pitchFamily="2" charset="0"/>
+              <a:cs typeface="CMU Serif Roman" panose="02000603000000000000" pitchFamily="2" charset="0"/>
+            </a:endParaRPr>
+          </a:p>
+        </p:txBody>
+      </p:sp>
     </p:spTree>
     <p:extLst>
       <p:ext uri="{BB962C8B-B14F-4D97-AF65-F5344CB8AC3E}">
@@ -11210,22 +11583,34 @@
           <a:lstStyle/>
           <a:p>
             <a:r>
-              <a:rPr lang="en-US" dirty="0"/>
+              <a:rPr lang="en-US" dirty="0">
+                <a:latin typeface="CMU Serif Roman" panose="02000603000000000000" pitchFamily="2" charset="0"/>
+                <a:ea typeface="CMU Serif Roman" panose="02000603000000000000" pitchFamily="2" charset="0"/>
+                <a:cs typeface="CMU Serif Roman" panose="02000603000000000000" pitchFamily="2" charset="0"/>
+              </a:rPr>
               <a:t>Low Rank Adaptation (</a:t>
             </a:r>
             <a:r>
-              <a:rPr lang="en-US" dirty="0" err="1"/>
+              <a:rPr lang="en-US" dirty="0" err="1">
+                <a:latin typeface="CMU Serif Roman" panose="02000603000000000000" pitchFamily="2" charset="0"/>
+                <a:ea typeface="CMU Serif Roman" panose="02000603000000000000" pitchFamily="2" charset="0"/>
+                <a:cs typeface="CMU Serif Roman" panose="02000603000000000000" pitchFamily="2" charset="0"/>
+              </a:rPr>
               <a:t>LoRA</a:t>
             </a:r>
             <a:r>
-              <a:rPr lang="en-US" dirty="0"/>
+              <a:rPr lang="en-US" dirty="0">
+                <a:latin typeface="CMU Serif Roman" panose="02000603000000000000" pitchFamily="2" charset="0"/>
+                <a:ea typeface="CMU Serif Roman" panose="02000603000000000000" pitchFamily="2" charset="0"/>
+                <a:cs typeface="CMU Serif Roman" panose="02000603000000000000" pitchFamily="2" charset="0"/>
+              </a:rPr>
               <a:t>)</a:t>
             </a:r>
           </a:p>
         </p:txBody>
       </p:sp>
-      <mc:AlternateContent xmlns:mc="http://schemas.openxmlformats.org/markup-compatibility/2006" xmlns:a14="http://schemas.microsoft.com/office/drawing/2010/main">
-        <mc:Choice Requires="a14">
+      <mc:AlternateContent xmlns:mc="http://schemas.openxmlformats.org/markup-compatibility/2006">
+        <mc:Choice xmlns:a14="http://schemas.microsoft.com/office/drawing/2010/main" Requires="a14">
           <p:sp>
             <p:nvSpPr>
               <p:cNvPr id="5" name="Content Placeholder 2">
@@ -11258,7 +11643,11 @@
                   <a:buNone/>
                 </a:pPr>
                 <a:r>
-                  <a:rPr lang="en-US" dirty="0"/>
+                  <a:rPr lang="en-US" sz="2400" dirty="0">
+                    <a:latin typeface="CMU Serif Roman" panose="02000603000000000000" pitchFamily="2" charset="0"/>
+                    <a:ea typeface="CMU Serif Roman" panose="02000603000000000000" pitchFamily="2" charset="0"/>
+                    <a:cs typeface="CMU Serif Roman" panose="02000603000000000000" pitchFamily="2" charset="0"/>
+                  </a:rPr>
                   <a:t>Checking the till…</a:t>
                 </a:r>
               </a:p>
@@ -11266,39 +11655,63 @@
                 <a:pPr marL="0" indent="0">
                   <a:buNone/>
                 </a:pPr>
-                <a:endParaRPr lang="en-US" dirty="0"/>
+                <a:endParaRPr lang="en-US" sz="2400" dirty="0">
+                  <a:latin typeface="CMU Serif Roman" panose="02000603000000000000" pitchFamily="2" charset="0"/>
+                  <a:ea typeface="CMU Serif Roman" panose="02000603000000000000" pitchFamily="2" charset="0"/>
+                  <a:cs typeface="CMU Serif Roman" panose="02000603000000000000" pitchFamily="2" charset="0"/>
+                </a:endParaRPr>
               </a:p>
               <a:p>
                 <a:r>
-                  <a:rPr lang="en-US" i="1" dirty="0"/>
+                  <a:rPr lang="en-US" sz="2400" i="1" dirty="0">
+                    <a:latin typeface="CMU SERIF ROMAN" panose="02000603000000000000" pitchFamily="2" charset="0"/>
+                    <a:ea typeface="CMU SERIF ROMAN" panose="02000603000000000000" pitchFamily="2" charset="0"/>
+                    <a:cs typeface="CMU SERIF ROMAN" panose="02000603000000000000" pitchFamily="2" charset="0"/>
+                  </a:rPr>
                   <a:t>Llama 3.1 70B</a:t>
                 </a:r>
               </a:p>
               <a:p>
                 <a:pPr lvl="1"/>
                 <a:r>
-                  <a:rPr lang="en-US" dirty="0"/>
+                  <a:rPr lang="en-US" sz="2000" dirty="0">
+                    <a:latin typeface="CMU Serif Roman" panose="02000603000000000000" pitchFamily="2" charset="0"/>
+                    <a:ea typeface="CMU Serif Roman" panose="02000603000000000000" pitchFamily="2" charset="0"/>
+                    <a:cs typeface="CMU Serif Roman" panose="02000603000000000000" pitchFamily="2" charset="0"/>
+                  </a:rPr>
                   <a:t>Rank 8 </a:t>
                 </a:r>
                 <a:r>
-                  <a:rPr lang="en-US" dirty="0" err="1"/>
+                  <a:rPr lang="en-US" sz="2000" dirty="0" err="1">
+                    <a:latin typeface="CMU Serif Roman" panose="02000603000000000000" pitchFamily="2" charset="0"/>
+                    <a:ea typeface="CMU Serif Roman" panose="02000603000000000000" pitchFamily="2" charset="0"/>
+                    <a:cs typeface="CMU Serif Roman" panose="02000603000000000000" pitchFamily="2" charset="0"/>
+                  </a:rPr>
                   <a:t>LoRA</a:t>
                 </a:r>
                 <a:r>
-                  <a:rPr lang="en-US" dirty="0"/>
+                  <a:rPr lang="en-US" sz="2000" dirty="0">
+                    <a:latin typeface="CMU Serif Roman" panose="02000603000000000000" pitchFamily="2" charset="0"/>
+                    <a:ea typeface="CMU Serif Roman" panose="02000603000000000000" pitchFamily="2" charset="0"/>
+                    <a:cs typeface="CMU Serif Roman" panose="02000603000000000000" pitchFamily="2" charset="0"/>
+                  </a:rPr>
                   <a:t> on attention only yields ~10M trainable parameters</a:t>
                 </a:r>
               </a:p>
               <a:p>
                 <a:pPr lvl="1"/>
                 <a:r>
-                  <a:rPr lang="en-US" dirty="0"/>
+                  <a:rPr lang="en-US" sz="2000" dirty="0">
+                    <a:latin typeface="CMU Serif Roman" panose="02000603000000000000" pitchFamily="2" charset="0"/>
+                    <a:ea typeface="CMU Serif Roman" panose="02000603000000000000" pitchFamily="2" charset="0"/>
+                    <a:cs typeface="CMU Serif Roman" panose="02000603000000000000" pitchFamily="2" charset="0"/>
+                  </a:rPr>
                   <a:t>10M </a:t>
                 </a:r>
                 <a14:m>
                   <m:oMath xmlns:m="http://schemas.openxmlformats.org/officeDocument/2006/math">
                     <m:r>
-                      <a:rPr lang="en-GB" b="0" i="1" smtClean="0">
+                      <a:rPr lang="en-GB" sz="2000" b="0" i="1" smtClean="0">
                         <a:latin typeface="Cambria Math" panose="02040503050406030204" pitchFamily="18" charset="0"/>
                       </a:rPr>
                       <m:t>× 8</m:t>
@@ -11306,79 +11719,139 @@
                   </m:oMath>
                 </a14:m>
                 <a:r>
-                  <a:rPr lang="en-GB" b="0" dirty="0"/>
+                  <a:rPr lang="en-GB" sz="2000" b="0" dirty="0">
+                    <a:latin typeface="CMU Serif Roman" panose="02000603000000000000" pitchFamily="2" charset="0"/>
+                    <a:ea typeface="CMU Serif Roman" panose="02000603000000000000" pitchFamily="2" charset="0"/>
+                    <a:cs typeface="CMU Serif Roman" panose="02000603000000000000" pitchFamily="2" charset="0"/>
+                  </a:rPr>
                   <a:t> ~ 80 MB for training state</a:t>
                 </a:r>
               </a:p>
               <a:p>
                 <a:r>
-                  <a:rPr lang="en-GB" dirty="0"/>
+                  <a:rPr lang="en-GB" sz="2400" dirty="0">
+                    <a:latin typeface="CMU Serif Roman" panose="02000603000000000000" pitchFamily="2" charset="0"/>
+                    <a:ea typeface="CMU Serif Roman" panose="02000603000000000000" pitchFamily="2" charset="0"/>
+                    <a:cs typeface="CMU Serif Roman" panose="02000603000000000000" pitchFamily="2" charset="0"/>
+                  </a:rPr>
                   <a:t>Base model weights still stored</a:t>
                 </a:r>
               </a:p>
               <a:p>
                 <a:pPr lvl="1"/>
                 <a:r>
-                  <a:rPr lang="en-GB" dirty="0"/>
+                  <a:rPr lang="en-GB" sz="2000" dirty="0">
+                    <a:latin typeface="CMU Serif Roman" panose="02000603000000000000" pitchFamily="2" charset="0"/>
+                    <a:ea typeface="CMU Serif Roman" panose="02000603000000000000" pitchFamily="2" charset="0"/>
+                    <a:cs typeface="CMU Serif Roman" panose="02000603000000000000" pitchFamily="2" charset="0"/>
+                  </a:rPr>
                   <a:t>Quantize to 4-bit (</a:t>
                 </a:r>
                 <a:r>
-                  <a:rPr lang="en-GB" i="1" dirty="0"/>
+                  <a:rPr lang="en-GB" sz="2000" i="1" dirty="0">
+                    <a:latin typeface="CMU SERIF ROMAN" panose="02000603000000000000" pitchFamily="2" charset="0"/>
+                    <a:ea typeface="CMU SERIF ROMAN" panose="02000603000000000000" pitchFamily="2" charset="0"/>
+                    <a:cs typeface="CMU SERIF ROMAN" panose="02000603000000000000" pitchFamily="2" charset="0"/>
+                  </a:rPr>
                   <a:t>int4</a:t>
                 </a:r>
                 <a:r>
-                  <a:rPr lang="en-GB" dirty="0"/>
+                  <a:rPr lang="en-GB" sz="2000" dirty="0">
+                    <a:latin typeface="CMU Serif Roman" panose="02000603000000000000" pitchFamily="2" charset="0"/>
+                    <a:ea typeface="CMU Serif Roman" panose="02000603000000000000" pitchFamily="2" charset="0"/>
+                    <a:cs typeface="CMU Serif Roman" panose="02000603000000000000" pitchFamily="2" charset="0"/>
+                  </a:rPr>
                   <a:t>), this is known as </a:t>
                 </a:r>
                 <a:r>
-                  <a:rPr lang="en-GB" dirty="0" err="1"/>
+                  <a:rPr lang="en-GB" sz="2000" dirty="0" err="1">
+                    <a:latin typeface="CMU Serif Roman" panose="02000603000000000000" pitchFamily="2" charset="0"/>
+                    <a:ea typeface="CMU Serif Roman" panose="02000603000000000000" pitchFamily="2" charset="0"/>
+                    <a:cs typeface="CMU Serif Roman" panose="02000603000000000000" pitchFamily="2" charset="0"/>
+                  </a:rPr>
                   <a:t>qLoRA</a:t>
                 </a:r>
                 <a:r>
-                  <a:rPr lang="en-GB" dirty="0"/>
+                  <a:rPr lang="en-GB" sz="2000" dirty="0">
+                    <a:latin typeface="CMU Serif Roman" panose="02000603000000000000" pitchFamily="2" charset="0"/>
+                    <a:ea typeface="CMU Serif Roman" panose="02000603000000000000" pitchFamily="2" charset="0"/>
+                    <a:cs typeface="CMU Serif Roman" panose="02000603000000000000" pitchFamily="2" charset="0"/>
+                  </a:rPr>
                   <a:t> (quantized </a:t>
                 </a:r>
                 <a:r>
-                  <a:rPr lang="en-GB" dirty="0" err="1"/>
+                  <a:rPr lang="en-GB" sz="2000" dirty="0" err="1">
+                    <a:latin typeface="CMU Serif Roman" panose="02000603000000000000" pitchFamily="2" charset="0"/>
+                    <a:ea typeface="CMU Serif Roman" panose="02000603000000000000" pitchFamily="2" charset="0"/>
+                    <a:cs typeface="CMU Serif Roman" panose="02000603000000000000" pitchFamily="2" charset="0"/>
+                  </a:rPr>
                   <a:t>LoRA</a:t>
                 </a:r>
                 <a:r>
-                  <a:rPr lang="en-GB" dirty="0"/>
+                  <a:rPr lang="en-GB" sz="2000" dirty="0">
+                    <a:latin typeface="CMU Serif Roman" panose="02000603000000000000" pitchFamily="2" charset="0"/>
+                    <a:ea typeface="CMU Serif Roman" panose="02000603000000000000" pitchFamily="2" charset="0"/>
+                    <a:cs typeface="CMU Serif Roman" panose="02000603000000000000" pitchFamily="2" charset="0"/>
+                  </a:rPr>
                   <a:t>)</a:t>
                 </a:r>
               </a:p>
               <a:p>
                 <a:pPr lvl="1"/>
                 <a:r>
-                  <a:rPr lang="en-GB" dirty="0"/>
+                  <a:rPr lang="en-GB" sz="2000" dirty="0">
+                    <a:latin typeface="CMU Serif Roman" panose="02000603000000000000" pitchFamily="2" charset="0"/>
+                    <a:ea typeface="CMU Serif Roman" panose="02000603000000000000" pitchFamily="2" charset="0"/>
+                    <a:cs typeface="CMU Serif Roman" panose="02000603000000000000" pitchFamily="2" charset="0"/>
+                  </a:rPr>
                   <a:t>Base model weights ~ 50 GB</a:t>
                 </a:r>
               </a:p>
               <a:p>
                 <a:r>
-                  <a:rPr lang="en-US" dirty="0"/>
+                  <a:rPr lang="en-US" sz="2400" dirty="0">
+                    <a:latin typeface="CMU Serif Roman" panose="02000603000000000000" pitchFamily="2" charset="0"/>
+                    <a:ea typeface="CMU Serif Roman" panose="02000603000000000000" pitchFamily="2" charset="0"/>
+                    <a:cs typeface="CMU Serif Roman" panose="02000603000000000000" pitchFamily="2" charset="0"/>
+                  </a:rPr>
                   <a:t>Total: ~50GB</a:t>
                 </a:r>
               </a:p>
               <a:p>
                 <a:r>
-                  <a:rPr lang="en-US" b="0" dirty="0"/>
+                  <a:rPr lang="en-US" sz="2400" b="0" dirty="0">
+                    <a:latin typeface="CMU Serif Roman" panose="02000603000000000000" pitchFamily="2" charset="0"/>
+                    <a:ea typeface="CMU Serif Roman" panose="02000603000000000000" pitchFamily="2" charset="0"/>
+                    <a:cs typeface="CMU Serif Roman" panose="02000603000000000000" pitchFamily="2" charset="0"/>
+                  </a:rPr>
                   <a:t>This can fit on a single </a:t>
                 </a:r>
                 <a:r>
-                  <a:rPr lang="en-US" dirty="0"/>
+                  <a:rPr lang="en-US" sz="2400" dirty="0">
+                    <a:latin typeface="CMU Serif Roman" panose="02000603000000000000" pitchFamily="2" charset="0"/>
+                    <a:ea typeface="CMU Serif Roman" panose="02000603000000000000" pitchFamily="2" charset="0"/>
+                    <a:cs typeface="CMU Serif Roman" panose="02000603000000000000" pitchFamily="2" charset="0"/>
+                  </a:rPr>
                   <a:t>80GB GPU</a:t>
                 </a:r>
                 <a:r>
-                  <a:rPr lang="en-US" b="0" dirty="0"/>
+                  <a:rPr lang="en-US" sz="2400" b="0" dirty="0">
+                    <a:latin typeface="CMU Serif Roman" panose="02000603000000000000" pitchFamily="2" charset="0"/>
+                    <a:ea typeface="CMU Serif Roman" panose="02000603000000000000" pitchFamily="2" charset="0"/>
+                    <a:cs typeface="CMU Serif Roman" panose="02000603000000000000" pitchFamily="2" charset="0"/>
+                  </a:rPr>
                   <a:t> very comfortably!</a:t>
                 </a:r>
-                <a:endParaRPr lang="en-GB" b="0" dirty="0"/>
+                <a:endParaRPr lang="en-GB" sz="2400" b="0" dirty="0">
+                  <a:latin typeface="CMU Serif Roman" panose="02000603000000000000" pitchFamily="2" charset="0"/>
+                  <a:ea typeface="CMU Serif Roman" panose="02000603000000000000" pitchFamily="2" charset="0"/>
+                  <a:cs typeface="CMU Serif Roman" panose="02000603000000000000" pitchFamily="2" charset="0"/>
+                </a:endParaRPr>
               </a:p>
             </p:txBody>
           </p:sp>
         </mc:Choice>
-        <mc:Fallback xmlns="">
+        <mc:Fallback>
           <p:sp>
             <p:nvSpPr>
               <p:cNvPr id="5" name="Content Placeholder 2">
@@ -11403,7 +11876,7 @@
               <a:blipFill>
                 <a:blip r:embed="rId2"/>
                 <a:stretch>
-                  <a:fillRect l="-1206" t="-2015"/>
+                  <a:fillRect l="-965" t="-1763"/>
                 </a:stretch>
               </a:blipFill>
             </p:spPr>
@@ -11444,8 +11917,8 @@
         </p:blipFill>
         <p:spPr>
           <a:xfrm>
-            <a:off x="3410680" y="2867000"/>
-            <a:ext cx="638802" cy="359326"/>
+            <a:off x="3219092" y="2797331"/>
+            <a:ext cx="499468" cy="280951"/>
           </a:xfrm>
           <a:prstGeom prst="rect">
             <a:avLst/>
@@ -11509,15 +11982,27 @@
           <a:lstStyle/>
           <a:p>
             <a:r>
-              <a:rPr lang="en-US" dirty="0"/>
+              <a:rPr lang="en-US" dirty="0">
+                <a:latin typeface="CMU Serif Roman" panose="02000603000000000000" pitchFamily="2" charset="0"/>
+                <a:ea typeface="CMU Serif Roman" panose="02000603000000000000" pitchFamily="2" charset="0"/>
+                <a:cs typeface="CMU Serif Roman" panose="02000603000000000000" pitchFamily="2" charset="0"/>
+              </a:rPr>
               <a:t>Quantized Low Rank Adaptation (</a:t>
             </a:r>
             <a:r>
-              <a:rPr lang="en-US" dirty="0" err="1"/>
+              <a:rPr lang="en-US" dirty="0" err="1">
+                <a:latin typeface="CMU Serif Roman" panose="02000603000000000000" pitchFamily="2" charset="0"/>
+                <a:ea typeface="CMU Serif Roman" panose="02000603000000000000" pitchFamily="2" charset="0"/>
+                <a:cs typeface="CMU Serif Roman" panose="02000603000000000000" pitchFamily="2" charset="0"/>
+              </a:rPr>
               <a:t>qLoRA</a:t>
             </a:r>
             <a:r>
-              <a:rPr lang="en-US" dirty="0"/>
+              <a:rPr lang="en-US" dirty="0">
+                <a:latin typeface="CMU Serif Roman" panose="02000603000000000000" pitchFamily="2" charset="0"/>
+                <a:ea typeface="CMU Serif Roman" panose="02000603000000000000" pitchFamily="2" charset="0"/>
+                <a:cs typeface="CMU Serif Roman" panose="02000603000000000000" pitchFamily="2" charset="0"/>
+              </a:rPr>
               <a:t>)</a:t>
             </a:r>
           </a:p>
@@ -11884,7 +12369,11 @@
           <a:lstStyle/>
           <a:p>
             <a:r>
-              <a:rPr lang="en-US" dirty="0"/>
+              <a:rPr lang="en-US" dirty="0">
+                <a:latin typeface="CMU Serif Roman" panose="02000603000000000000" pitchFamily="2" charset="0"/>
+                <a:ea typeface="CMU Serif Roman" panose="02000603000000000000" pitchFamily="2" charset="0"/>
+                <a:cs typeface="CMU Serif Roman" panose="02000603000000000000" pitchFamily="2" charset="0"/>
+              </a:rPr>
               <a:t>Look Familiar?</a:t>
             </a:r>
           </a:p>
@@ -11943,7 +12432,7 @@
         </p:blipFill>
         <p:spPr>
           <a:xfrm>
-            <a:off x="5359652" y="3566693"/>
+            <a:off x="5359652" y="3082708"/>
             <a:ext cx="4689694" cy="1927379"/>
           </a:xfrm>
           <a:prstGeom prst="rect">
@@ -11973,7 +12462,7 @@
         </p:blipFill>
         <p:spPr>
           <a:xfrm>
-            <a:off x="5359652" y="5494072"/>
+            <a:off x="5359652" y="5010087"/>
             <a:ext cx="4689694" cy="998803"/>
           </a:xfrm>
           <a:prstGeom prst="rect">
@@ -12021,17 +12510,30 @@
             <p:ph type="ctrTitle"/>
           </p:nvPr>
         </p:nvSpPr>
-        <p:spPr/>
+        <p:spPr>
+          <a:xfrm>
+            <a:off x="1523999" y="1122363"/>
+            <a:ext cx="9927771" cy="2387600"/>
+          </a:xfrm>
+        </p:spPr>
         <p:txBody>
           <a:bodyPr/>
           <a:lstStyle/>
           <a:p>
             <a:pPr algn="l"/>
             <a:r>
-              <a:rPr lang="en-GB" dirty="0"/>
+              <a:rPr lang="en-GB" dirty="0">
+                <a:latin typeface="CMU Serif Roman" panose="02000603000000000000" pitchFamily="2" charset="0"/>
+                <a:ea typeface="CMU Serif Roman" panose="02000603000000000000" pitchFamily="2" charset="0"/>
+                <a:cs typeface="CMU Serif Roman" panose="02000603000000000000" pitchFamily="2" charset="0"/>
+              </a:rPr>
               <a:t>Post-training &amp; Fine-tuning</a:t>
             </a:r>
-            <a:endParaRPr lang="en-US" dirty="0"/>
+            <a:endParaRPr lang="en-US" dirty="0">
+              <a:latin typeface="CMU Serif Roman" panose="02000603000000000000" pitchFamily="2" charset="0"/>
+              <a:ea typeface="CMU Serif Roman" panose="02000603000000000000" pitchFamily="2" charset="0"/>
+              <a:cs typeface="CMU Serif Roman" panose="02000603000000000000" pitchFamily="2" charset="0"/>
+            </a:endParaRPr>
           </a:p>
         </p:txBody>
       </p:sp>
@@ -12054,10 +12556,18 @@
           <a:p>
             <a:pPr algn="l"/>
             <a:r>
-              <a:rPr lang="en-GB" dirty="0"/>
+              <a:rPr lang="en-GB" dirty="0">
+                <a:latin typeface="CMU Serif Roman" panose="02000603000000000000" pitchFamily="2" charset="0"/>
+                <a:ea typeface="CMU Serif Roman" panose="02000603000000000000" pitchFamily="2" charset="0"/>
+                <a:cs typeface="CMU Serif Roman" panose="02000603000000000000" pitchFamily="2" charset="0"/>
+              </a:rPr>
               <a:t>This can be hard...</a:t>
             </a:r>
-            <a:endParaRPr lang="en-US" dirty="0"/>
+            <a:endParaRPr lang="en-US" dirty="0">
+              <a:latin typeface="CMU Serif Roman" panose="02000603000000000000" pitchFamily="2" charset="0"/>
+              <a:ea typeface="CMU Serif Roman" panose="02000603000000000000" pitchFamily="2" charset="0"/>
+              <a:cs typeface="CMU Serif Roman" panose="02000603000000000000" pitchFamily="2" charset="0"/>
+            </a:endParaRPr>
           </a:p>
         </p:txBody>
       </p:sp>
@@ -12083,7 +12593,7 @@
         </p:blipFill>
         <p:spPr>
           <a:xfrm>
-            <a:off x="9729884" y="3844540"/>
+            <a:off x="9729883" y="3509963"/>
             <a:ext cx="1876233" cy="2809587"/>
           </a:xfrm>
           <a:prstGeom prst="rect">
@@ -12143,7 +12653,11 @@
           <a:lstStyle/>
           <a:p>
             <a:r>
-              <a:rPr lang="en-GB" dirty="0"/>
+              <a:rPr lang="en-GB" dirty="0">
+                <a:latin typeface="CMU Serif Roman" panose="02000603000000000000" pitchFamily="2" charset="0"/>
+                <a:ea typeface="CMU Serif Roman" panose="02000603000000000000" pitchFamily="2" charset="0"/>
+                <a:cs typeface="CMU Serif Roman" panose="02000603000000000000" pitchFamily="2" charset="0"/>
+              </a:rPr>
               <a:t>Overview</a:t>
             </a:r>
           </a:p>
@@ -12173,30 +12687,58 @@
           <a:lstStyle/>
           <a:p>
             <a:r>
-              <a:rPr lang="en-GB" dirty="0"/>
+              <a:rPr lang="en-GB" dirty="0">
+                <a:latin typeface="CMU Serif Roman" panose="02000603000000000000" pitchFamily="2" charset="0"/>
+                <a:ea typeface="CMU Serif Roman" panose="02000603000000000000" pitchFamily="2" charset="0"/>
+                <a:cs typeface="CMU Serif Roman" panose="02000603000000000000" pitchFamily="2" charset="0"/>
+              </a:rPr>
               <a:t>Post-training vs. Fine-tuning</a:t>
             </a:r>
           </a:p>
           <a:p>
             <a:r>
-              <a:rPr lang="en-GB" dirty="0"/>
+              <a:rPr lang="en-GB" dirty="0">
+                <a:latin typeface="CMU Serif Roman" panose="02000603000000000000" pitchFamily="2" charset="0"/>
+                <a:ea typeface="CMU Serif Roman" panose="02000603000000000000" pitchFamily="2" charset="0"/>
+                <a:cs typeface="CMU Serif Roman" panose="02000603000000000000" pitchFamily="2" charset="0"/>
+              </a:rPr>
               <a:t>Instruction tuning</a:t>
             </a:r>
-            <a:endParaRPr lang="en-US" dirty="0"/>
-          </a:p>
-          <a:p>
-            <a:r>
-              <a:rPr lang="en-GB" dirty="0" err="1"/>
+            <a:endParaRPr lang="en-US" dirty="0">
+              <a:latin typeface="CMU Serif Roman" panose="02000603000000000000" pitchFamily="2" charset="0"/>
+              <a:ea typeface="CMU Serif Roman" panose="02000603000000000000" pitchFamily="2" charset="0"/>
+              <a:cs typeface="CMU Serif Roman" panose="02000603000000000000" pitchFamily="2" charset="0"/>
+            </a:endParaRPr>
+          </a:p>
+          <a:p>
+            <a:r>
+              <a:rPr lang="en-GB" dirty="0" err="1">
+                <a:latin typeface="CMU Serif Roman" panose="02000603000000000000" pitchFamily="2" charset="0"/>
+                <a:ea typeface="CMU Serif Roman" panose="02000603000000000000" pitchFamily="2" charset="0"/>
+                <a:cs typeface="CMU Serif Roman" panose="02000603000000000000" pitchFamily="2" charset="0"/>
+              </a:rPr>
               <a:t>LoRA</a:t>
             </a:r>
-            <a:endParaRPr lang="en-GB" dirty="0"/>
-          </a:p>
-          <a:p>
-            <a:r>
-              <a:rPr lang="en-GB" dirty="0" err="1"/>
+            <a:endParaRPr lang="en-GB" dirty="0">
+              <a:latin typeface="CMU Serif Roman" panose="02000603000000000000" pitchFamily="2" charset="0"/>
+              <a:ea typeface="CMU Serif Roman" panose="02000603000000000000" pitchFamily="2" charset="0"/>
+              <a:cs typeface="CMU Serif Roman" panose="02000603000000000000" pitchFamily="2" charset="0"/>
+            </a:endParaRPr>
+          </a:p>
+          <a:p>
+            <a:r>
+              <a:rPr lang="en-GB" dirty="0" err="1">
+                <a:latin typeface="CMU Serif Roman" panose="02000603000000000000" pitchFamily="2" charset="0"/>
+                <a:ea typeface="CMU Serif Roman" panose="02000603000000000000" pitchFamily="2" charset="0"/>
+                <a:cs typeface="CMU Serif Roman" panose="02000603000000000000" pitchFamily="2" charset="0"/>
+              </a:rPr>
               <a:t>qLoRA</a:t>
             </a:r>
-            <a:endParaRPr lang="en-GB" dirty="0"/>
+            <a:endParaRPr lang="en-GB" dirty="0">
+              <a:latin typeface="CMU Serif Roman" panose="02000603000000000000" pitchFamily="2" charset="0"/>
+              <a:ea typeface="CMU Serif Roman" panose="02000603000000000000" pitchFamily="2" charset="0"/>
+              <a:cs typeface="CMU Serif Roman" panose="02000603000000000000" pitchFamily="2" charset="0"/>
+            </a:endParaRPr>
           </a:p>
         </p:txBody>
       </p:sp>
@@ -12252,7 +12794,11 @@
           <a:lstStyle/>
           <a:p>
             <a:r>
-              <a:rPr lang="en-US" dirty="0"/>
+              <a:rPr lang="en-US" dirty="0">
+                <a:latin typeface="CMU Serif Roman" panose="02000603000000000000" pitchFamily="2" charset="0"/>
+                <a:ea typeface="CMU Serif Roman" panose="02000603000000000000" pitchFamily="2" charset="0"/>
+                <a:cs typeface="CMU Serif Roman" panose="02000603000000000000" pitchFamily="2" charset="0"/>
+              </a:rPr>
               <a:t>Post-training vs. Fine-tuning</a:t>
             </a:r>
           </a:p>
@@ -12283,19 +12829,35 @@
               <a:buNone/>
             </a:pPr>
             <a:r>
-              <a:rPr lang="en-GB" dirty="0"/>
+              <a:rPr lang="en-GB" dirty="0">
+                <a:latin typeface="CMU Serif Roman" panose="02000603000000000000" pitchFamily="2" charset="0"/>
+                <a:ea typeface="CMU Serif Roman" panose="02000603000000000000" pitchFamily="2" charset="0"/>
+                <a:cs typeface="CMU Serif Roman" panose="02000603000000000000" pitchFamily="2" charset="0"/>
+              </a:rPr>
               <a:t>Post-training refers to </a:t>
             </a:r>
             <a:r>
-              <a:rPr lang="en-GB" b="1" dirty="0"/>
+              <a:rPr lang="en-GB" b="1" dirty="0">
+                <a:latin typeface="CMU SERIF ROMAN" panose="02000603000000000000" pitchFamily="2" charset="0"/>
+                <a:ea typeface="CMU SERIF ROMAN" panose="02000603000000000000" pitchFamily="2" charset="0"/>
+                <a:cs typeface="CMU SERIF ROMAN" panose="02000603000000000000" pitchFamily="2" charset="0"/>
+              </a:rPr>
               <a:t>everything that happens after the initial pre-training</a:t>
             </a:r>
             <a:r>
-              <a:rPr lang="en-GB" dirty="0"/>
+              <a:rPr lang="en-GB" dirty="0">
+                <a:latin typeface="CMU Serif Roman" panose="02000603000000000000" pitchFamily="2" charset="0"/>
+                <a:ea typeface="CMU Serif Roman" panose="02000603000000000000" pitchFamily="2" charset="0"/>
+                <a:cs typeface="CMU Serif Roman" panose="02000603000000000000" pitchFamily="2" charset="0"/>
+              </a:rPr>
               <a:t> phase. It's an umbrella term covering all techniques used to shape model behaviour or align it with human preferences</a:t>
             </a:r>
             <a:r>
-              <a:rPr lang="en-US" dirty="0"/>
+              <a:rPr lang="en-US" dirty="0">
+                <a:latin typeface="CMU Serif Roman" panose="02000603000000000000" pitchFamily="2" charset="0"/>
+                <a:ea typeface="CMU Serif Roman" panose="02000603000000000000" pitchFamily="2" charset="0"/>
+                <a:cs typeface="CMU Serif Roman" panose="02000603000000000000" pitchFamily="2" charset="0"/>
+              </a:rPr>
               <a:t>. It includes:</a:t>
             </a:r>
           </a:p>
@@ -12303,29 +12865,49 @@
             <a:pPr marL="0" indent="0">
               <a:buNone/>
             </a:pPr>
-            <a:endParaRPr lang="en-US" dirty="0"/>
-          </a:p>
-          <a:p>
-            <a:r>
-              <a:rPr lang="en-US" dirty="0"/>
+            <a:endParaRPr lang="en-US" dirty="0">
+              <a:latin typeface="CMU Serif Roman" panose="02000603000000000000" pitchFamily="2" charset="0"/>
+              <a:ea typeface="CMU Serif Roman" panose="02000603000000000000" pitchFamily="2" charset="0"/>
+              <a:cs typeface="CMU Serif Roman" panose="02000603000000000000" pitchFamily="2" charset="0"/>
+            </a:endParaRPr>
+          </a:p>
+          <a:p>
+            <a:r>
+              <a:rPr lang="en-US" dirty="0">
+                <a:latin typeface="CMU Serif Roman" panose="02000603000000000000" pitchFamily="2" charset="0"/>
+                <a:ea typeface="CMU Serif Roman" panose="02000603000000000000" pitchFamily="2" charset="0"/>
+                <a:cs typeface="CMU Serif Roman" panose="02000603000000000000" pitchFamily="2" charset="0"/>
+              </a:rPr>
               <a:t>Supervised fine-tuning (e.g. instruction tuning)</a:t>
             </a:r>
           </a:p>
           <a:p>
             <a:r>
-              <a:rPr lang="en-US" dirty="0"/>
+              <a:rPr lang="en-US" dirty="0">
+                <a:latin typeface="CMU Serif Roman" panose="02000603000000000000" pitchFamily="2" charset="0"/>
+                <a:ea typeface="CMU Serif Roman" panose="02000603000000000000" pitchFamily="2" charset="0"/>
+                <a:cs typeface="CMU Serif Roman" panose="02000603000000000000" pitchFamily="2" charset="0"/>
+              </a:rPr>
               <a:t>RLHF (Reinforcement Learning from Human Feedback)</a:t>
             </a:r>
           </a:p>
           <a:p>
             <a:r>
-              <a:rPr lang="en-US" dirty="0"/>
+              <a:rPr lang="en-US" dirty="0">
+                <a:latin typeface="CMU Serif Roman" panose="02000603000000000000" pitchFamily="2" charset="0"/>
+                <a:ea typeface="CMU Serif Roman" panose="02000603000000000000" pitchFamily="2" charset="0"/>
+                <a:cs typeface="CMU Serif Roman" panose="02000603000000000000" pitchFamily="2" charset="0"/>
+              </a:rPr>
               <a:t>RLVR (Reinforcement Learning from Verifiable Rewards)</a:t>
             </a:r>
           </a:p>
           <a:p>
             <a:r>
-              <a:rPr lang="en-US" dirty="0"/>
+              <a:rPr lang="en-US" dirty="0">
+                <a:latin typeface="CMU Serif Roman" panose="02000603000000000000" pitchFamily="2" charset="0"/>
+                <a:ea typeface="CMU Serif Roman" panose="02000603000000000000" pitchFamily="2" charset="0"/>
+                <a:cs typeface="CMU Serif Roman" panose="02000603000000000000" pitchFamily="2" charset="0"/>
+              </a:rPr>
               <a:t>Constitutional AI</a:t>
             </a:r>
           </a:p>
@@ -12354,7 +12936,7 @@
         </p:blipFill>
         <p:spPr>
           <a:xfrm>
-            <a:off x="3791096" y="5512986"/>
+            <a:off x="4034936" y="5504277"/>
             <a:ext cx="497305" cy="522171"/>
           </a:xfrm>
           <a:prstGeom prst="rect">
@@ -12842,7 +13424,11 @@
               <a:buNone/>
             </a:pPr>
             <a:r>
-              <a:rPr lang="en-US"/>
+              <a:rPr lang="en-US" dirty="0">
+                <a:latin typeface="CMU Serif Roman" panose="02000603000000000000" pitchFamily="2" charset="0"/>
+                <a:ea typeface="CMU Serif Roman" panose="02000603000000000000" pitchFamily="2" charset="0"/>
+                <a:cs typeface="CMU Serif Roman" panose="02000603000000000000" pitchFamily="2" charset="0"/>
+              </a:rPr>
               <a:t>Fine-tuning refers to adapting a pre-trained foundation model to a specific downstream task / domain via post-training on a usually small specialized dataset.</a:t>
             </a:r>
           </a:p>
@@ -12851,7 +13437,11 @@
               <a:buFont typeface="Arial" panose="020B0604020202020204" pitchFamily="34" charset="0"/>
               <a:buNone/>
             </a:pPr>
-            <a:endParaRPr lang="en-US" dirty="0"/>
+            <a:endParaRPr lang="en-US" dirty="0">
+              <a:latin typeface="CMU Serif Roman" panose="02000603000000000000" pitchFamily="2" charset="0"/>
+              <a:ea typeface="CMU Serif Roman" panose="02000603000000000000" pitchFamily="2" charset="0"/>
+              <a:cs typeface="CMU Serif Roman" panose="02000603000000000000" pitchFamily="2" charset="0"/>
+            </a:endParaRPr>
           </a:p>
         </p:txBody>
       </p:sp>
@@ -12871,7 +13461,7 @@
         </p:nvSpPr>
         <p:spPr>
           <a:xfrm>
-            <a:off x="8740464" y="6158508"/>
+            <a:off x="8932052" y="5623147"/>
             <a:ext cx="3118738" cy="529390"/>
           </a:xfrm>
           <a:prstGeom prst="rect">
@@ -13056,8 +13646,12 @@
                 <a:solidFill>
                   <a:schemeClr val="tx1">
                     <a:lumMod val="50000"/>
+                    <a:lumOff val="50000"/>
                   </a:schemeClr>
                 </a:solidFill>
+                <a:latin typeface="CMU Serif Roman" panose="02000603000000000000" pitchFamily="2" charset="0"/>
+                <a:ea typeface="CMU Serif Roman" panose="02000603000000000000" pitchFamily="2" charset="0"/>
+                <a:cs typeface="CMU Serif Roman" panose="02000603000000000000" pitchFamily="2" charset="0"/>
               </a:rPr>
               <a:t>Source: Google Cloud</a:t>
             </a:r>
@@ -13067,17 +13661,25 @@
               <a:solidFill>
                 <a:schemeClr val="tx1">
                   <a:lumMod val="50000"/>
+                  <a:lumOff val="50000"/>
                 </a:schemeClr>
               </a:solidFill>
+              <a:latin typeface="CMU Serif Roman" panose="02000603000000000000" pitchFamily="2" charset="0"/>
+              <a:ea typeface="CMU Serif Roman" panose="02000603000000000000" pitchFamily="2" charset="0"/>
+              <a:cs typeface="CMU Serif Roman" panose="02000603000000000000" pitchFamily="2" charset="0"/>
             </a:endParaRPr>
           </a:p>
           <a:p>
             <a:endParaRPr lang="en-US" sz="2400" dirty="0">
               <a:solidFill>
                 <a:schemeClr val="tx1">
-                  <a:lumMod val="85000"/>
+                  <a:lumMod val="50000"/>
+                  <a:lumOff val="50000"/>
                 </a:schemeClr>
               </a:solidFill>
+              <a:latin typeface="CMU Serif Roman" panose="02000603000000000000" pitchFamily="2" charset="0"/>
+              <a:ea typeface="CMU Serif Roman" panose="02000603000000000000" pitchFamily="2" charset="0"/>
+              <a:cs typeface="CMU Serif Roman" panose="02000603000000000000" pitchFamily="2" charset="0"/>
             </a:endParaRPr>
           </a:p>
         </p:txBody>
@@ -13164,7 +13766,11 @@
           <a:lstStyle/>
           <a:p>
             <a:r>
-              <a:rPr lang="en-GB" dirty="0"/>
+              <a:rPr lang="en-GB" dirty="0">
+                <a:latin typeface="CMU Serif Roman" panose="02000603000000000000" pitchFamily="2" charset="0"/>
+                <a:ea typeface="CMU Serif Roman" panose="02000603000000000000" pitchFamily="2" charset="0"/>
+                <a:cs typeface="CMU Serif Roman" panose="02000603000000000000" pitchFamily="2" charset="0"/>
+              </a:rPr>
               <a:t>Instruction tuning</a:t>
             </a:r>
           </a:p>
@@ -13197,23 +13803,39 @@
               <a:buNone/>
             </a:pPr>
             <a:r>
-              <a:rPr lang="en-GB" dirty="0"/>
+              <a:rPr lang="en-GB" dirty="0">
+                <a:latin typeface="CMU Serif Roman" panose="02000603000000000000" pitchFamily="2" charset="0"/>
+                <a:ea typeface="CMU Serif Roman" panose="02000603000000000000" pitchFamily="2" charset="0"/>
+                <a:cs typeface="CMU Serif Roman" panose="02000603000000000000" pitchFamily="2" charset="0"/>
+              </a:rPr>
               <a:t>We have been doing next token prediction on trillions of tokens...</a:t>
             </a:r>
-            <a:endParaRPr lang="en-US" dirty="0"/>
+            <a:endParaRPr lang="en-US" dirty="0">
+              <a:latin typeface="CMU Serif Roman" panose="02000603000000000000" pitchFamily="2" charset="0"/>
+              <a:ea typeface="CMU Serif Roman" panose="02000603000000000000" pitchFamily="2" charset="0"/>
+              <a:cs typeface="CMU Serif Roman" panose="02000603000000000000" pitchFamily="2" charset="0"/>
+            </a:endParaRPr>
           </a:p>
           <a:p>
             <a:pPr marL="0" indent="0">
               <a:buNone/>
             </a:pPr>
-            <a:endParaRPr lang="en-GB" dirty="0"/>
+            <a:endParaRPr lang="en-GB" dirty="0">
+              <a:latin typeface="CMU Serif Roman" panose="02000603000000000000" pitchFamily="2" charset="0"/>
+              <a:ea typeface="CMU Serif Roman" panose="02000603000000000000" pitchFamily="2" charset="0"/>
+              <a:cs typeface="CMU Serif Roman" panose="02000603000000000000" pitchFamily="2" charset="0"/>
+            </a:endParaRPr>
           </a:p>
           <a:p>
             <a:pPr marL="0" indent="0">
               <a:buNone/>
             </a:pPr>
             <a:r>
-              <a:rPr lang="en-GB" dirty="0"/>
+              <a:rPr lang="en-GB" dirty="0">
+                <a:latin typeface="CMU Serif Roman" panose="02000603000000000000" pitchFamily="2" charset="0"/>
+                <a:ea typeface="CMU Serif Roman" panose="02000603000000000000" pitchFamily="2" charset="0"/>
+                <a:cs typeface="CMU Serif Roman" panose="02000603000000000000" pitchFamily="2" charset="0"/>
+              </a:rPr>
               <a:t>...and that's it...</a:t>
             </a:r>
           </a:p>
@@ -13221,14 +13843,22 @@
             <a:pPr marL="0" indent="0">
               <a:buNone/>
             </a:pPr>
-            <a:endParaRPr lang="en-GB" dirty="0"/>
+            <a:endParaRPr lang="en-GB" dirty="0">
+              <a:latin typeface="CMU Serif Roman" panose="02000603000000000000" pitchFamily="2" charset="0"/>
+              <a:ea typeface="CMU Serif Roman" panose="02000603000000000000" pitchFamily="2" charset="0"/>
+              <a:cs typeface="CMU Serif Roman" panose="02000603000000000000" pitchFamily="2" charset="0"/>
+            </a:endParaRPr>
           </a:p>
           <a:p>
             <a:pPr marL="0" indent="0">
               <a:buNone/>
             </a:pPr>
             <a:r>
-              <a:rPr lang="en-GB" dirty="0"/>
+              <a:rPr lang="en-GB" dirty="0">
+                <a:latin typeface="CMU Serif Roman" panose="02000603000000000000" pitchFamily="2" charset="0"/>
+                <a:ea typeface="CMU Serif Roman" panose="02000603000000000000" pitchFamily="2" charset="0"/>
+                <a:cs typeface="CMU Serif Roman" panose="02000603000000000000" pitchFamily="2" charset="0"/>
+              </a:rPr>
               <a:t>We've built a very expensive next word predictor</a:t>
             </a:r>
           </a:p>
@@ -13236,21 +13866,32 @@
             <a:pPr marL="0" indent="0">
               <a:buNone/>
             </a:pPr>
-            <a:endParaRPr lang="en-GB" dirty="0"/>
+            <a:endParaRPr lang="en-GB" dirty="0">
+              <a:latin typeface="CMU Serif Roman" panose="02000603000000000000" pitchFamily="2" charset="0"/>
+              <a:ea typeface="CMU Serif Roman" panose="02000603000000000000" pitchFamily="2" charset="0"/>
+              <a:cs typeface="CMU Serif Roman" panose="02000603000000000000" pitchFamily="2" charset="0"/>
+            </a:endParaRPr>
           </a:p>
           <a:p>
             <a:pPr marL="0" indent="0">
               <a:buNone/>
             </a:pPr>
             <a:r>
-              <a:rPr lang="en-GB" dirty="0"/>
+              <a:rPr lang="en-GB" dirty="0">
+                <a:latin typeface="CMU Serif Roman" panose="02000603000000000000" pitchFamily="2" charset="0"/>
+                <a:ea typeface="CMU Serif Roman" panose="02000603000000000000" pitchFamily="2" charset="0"/>
+                <a:cs typeface="CMU Serif Roman" panose="02000603000000000000" pitchFamily="2" charset="0"/>
+              </a:rPr>
               <a:t>We want an </a:t>
             </a:r>
             <a:r>
               <a:rPr lang="en-GB" b="1" i="1" dirty="0">
                 <a:solidFill>
-                  <a:srgbClr val="7030A0"/>
-                </a:solidFill>
+                  <a:srgbClr val="1B55EB"/>
+                </a:solidFill>
+                <a:latin typeface="CMU SERIF ROMAN" panose="02000603000000000000" pitchFamily="2" charset="0"/>
+                <a:ea typeface="CMU SERIF ROMAN" panose="02000603000000000000" pitchFamily="2" charset="0"/>
+                <a:cs typeface="CMU SERIF ROMAN" panose="02000603000000000000" pitchFamily="2" charset="0"/>
               </a:rPr>
               <a:t>assistant</a:t>
             </a:r>
@@ -13544,10 +14185,18 @@
           <a:lstStyle/>
           <a:p>
             <a:r>
-              <a:rPr lang="en-GB" dirty="0"/>
+              <a:rPr lang="en-GB" dirty="0">
+                <a:latin typeface="CMU Serif Roman" panose="02000603000000000000" pitchFamily="2" charset="0"/>
+                <a:ea typeface="CMU Serif Roman" panose="02000603000000000000" pitchFamily="2" charset="0"/>
+                <a:cs typeface="CMU Serif Roman" panose="02000603000000000000" pitchFamily="2" charset="0"/>
+              </a:rPr>
               <a:t>Instruction tuning</a:t>
             </a:r>
-            <a:endParaRPr lang="en-US" dirty="0"/>
+            <a:endParaRPr lang="en-US" dirty="0">
+              <a:latin typeface="CMU Serif Roman" panose="02000603000000000000" pitchFamily="2" charset="0"/>
+              <a:ea typeface="CMU Serif Roman" panose="02000603000000000000" pitchFamily="2" charset="0"/>
+              <a:cs typeface="CMU Serif Roman" panose="02000603000000000000" pitchFamily="2" charset="0"/>
+            </a:endParaRPr>
           </a:p>
         </p:txBody>
       </p:sp>
@@ -13636,7 +14285,7 @@
             <a:r>
               <a:rPr lang="en-GB" sz="1700" dirty="0">
                 <a:solidFill>
-                  <a:srgbClr val="0B7743"/>
+                  <a:srgbClr val="1B55EB"/>
                 </a:solidFill>
                 <a:latin typeface="Source Code Pro"/>
                 <a:ea typeface="Source Code Pro"/>
@@ -13800,7 +14449,7 @@
             <a:r>
               <a:rPr lang="en-GB" sz="1700" dirty="0">
                 <a:solidFill>
-                  <a:srgbClr val="0B7743"/>
+                  <a:srgbClr val="1B55EB"/>
                 </a:solidFill>
                 <a:latin typeface="Source Code Pro"/>
                 <a:ea typeface="Source Code Pro"/>
@@ -13876,7 +14525,7 @@
               <a:t>&lt;|</a:t>
             </a:r>
             <a:r>
-              <a:rPr lang="en-GB" sz="1700" err="1">
+              <a:rPr lang="en-GB" sz="1700" dirty="0" err="1">
                 <a:solidFill>
                   <a:srgbClr val="666666"/>
                 </a:solidFill>
@@ -13964,7 +14613,7 @@
             <a:r>
               <a:rPr lang="en-GB" sz="1700" dirty="0">
                 <a:solidFill>
-                  <a:srgbClr val="0B7743"/>
+                  <a:srgbClr val="1B55EB"/>
                 </a:solidFill>
                 <a:latin typeface="Source Code Pro"/>
                 <a:ea typeface="Source Code Pro"/>
@@ -15315,7 +15964,9 @@
           <a:p>
             <a:r>
               <a:rPr lang="en-GB" sz="2800" b="1" dirty="0">
-                <a:latin typeface="IBM Plex Mono"/>
+                <a:latin typeface="CMU SERIF ROMAN" panose="02000603000000000000" pitchFamily="2" charset="0"/>
+                <a:ea typeface="CMU SERIF ROMAN" panose="02000603000000000000" pitchFamily="2" charset="0"/>
+                <a:cs typeface="CMU SERIF ROMAN" panose="02000603000000000000" pitchFamily="2" charset="0"/>
               </a:rPr>
               <a:t>special tokens</a:t>
             </a:r>
@@ -15738,10 +16389,18 @@
           <a:lstStyle/>
           <a:p>
             <a:r>
-              <a:rPr lang="en-GB" dirty="0"/>
+              <a:rPr lang="en-GB" dirty="0">
+                <a:latin typeface="CMU Serif Roman" panose="02000603000000000000" pitchFamily="2" charset="0"/>
+                <a:ea typeface="CMU Serif Roman" panose="02000603000000000000" pitchFamily="2" charset="0"/>
+                <a:cs typeface="CMU Serif Roman" panose="02000603000000000000" pitchFamily="2" charset="0"/>
+              </a:rPr>
               <a:t>Instruction tuning</a:t>
             </a:r>
-            <a:endParaRPr lang="en-US" dirty="0"/>
+            <a:endParaRPr lang="en-US" dirty="0">
+              <a:latin typeface="CMU Serif Roman" panose="02000603000000000000" pitchFamily="2" charset="0"/>
+              <a:ea typeface="CMU Serif Roman" panose="02000603000000000000" pitchFamily="2" charset="0"/>
+              <a:cs typeface="CMU Serif Roman" panose="02000603000000000000" pitchFamily="2" charset="0"/>
+            </a:endParaRPr>
           </a:p>
         </p:txBody>
       </p:sp>
@@ -15830,7 +16489,7 @@
             <a:r>
               <a:rPr lang="en-GB" sz="1700" dirty="0">
                 <a:solidFill>
-                  <a:srgbClr val="0B7743"/>
+                  <a:srgbClr val="1B55EB"/>
                 </a:solidFill>
                 <a:latin typeface="Source Code Pro"/>
                 <a:ea typeface="Source Code Pro"/>
@@ -15994,7 +16653,7 @@
             <a:r>
               <a:rPr lang="en-GB" sz="1700" dirty="0">
                 <a:solidFill>
-                  <a:srgbClr val="0B7743"/>
+                  <a:srgbClr val="1B55EB"/>
                 </a:solidFill>
                 <a:latin typeface="Source Code Pro"/>
                 <a:ea typeface="Source Code Pro"/>
@@ -16070,7 +16729,7 @@
               <a:t>&lt;|</a:t>
             </a:r>
             <a:r>
-              <a:rPr lang="en-GB" sz="1700" err="1">
+              <a:rPr lang="en-GB" sz="1700" dirty="0" err="1">
                 <a:solidFill>
                   <a:srgbClr val="666666"/>
                 </a:solidFill>
@@ -16158,7 +16817,7 @@
             <a:r>
               <a:rPr lang="en-GB" sz="1700" dirty="0">
                 <a:solidFill>
-                  <a:srgbClr val="0B7743"/>
+                  <a:srgbClr val="1B55EB"/>
                 </a:solidFill>
                 <a:latin typeface="Source Code Pro"/>
                 <a:ea typeface="Source Code Pro"/>
@@ -16309,17 +16968,16 @@
           <a:p>
             <a:r>
               <a:rPr lang="en-GB" sz="2800" b="1" dirty="0">
-                <a:solidFill>
-                  <a:schemeClr val="accent3"/>
-                </a:solidFill>
-                <a:latin typeface="IBM Plex Mono"/>
+                <a:latin typeface="CMU SERIF ROMAN" panose="02000603000000000000" pitchFamily="2" charset="0"/>
+                <a:ea typeface="CMU SERIF ROMAN" panose="02000603000000000000" pitchFamily="2" charset="0"/>
+                <a:cs typeface="CMU SERIF ROMAN" panose="02000603000000000000" pitchFamily="2" charset="0"/>
               </a:rPr>
               <a:t>role</a:t>
             </a:r>
-            <a:endParaRPr lang="en-US">
-              <a:solidFill>
-                <a:schemeClr val="accent3"/>
-              </a:solidFill>
+            <a:endParaRPr lang="en-US" dirty="0">
+              <a:latin typeface="CMU Serif Roman" panose="02000603000000000000" pitchFamily="2" charset="0"/>
+              <a:ea typeface="CMU Serif Roman" panose="02000603000000000000" pitchFamily="2" charset="0"/>
+              <a:cs typeface="CMU Serif Roman" panose="02000603000000000000" pitchFamily="2" charset="0"/>
             </a:endParaRPr>
           </a:p>
         </p:txBody>
@@ -16406,7 +17064,7 @@
           <a:noFill/>
           <a:ln>
             <a:solidFill>
-              <a:schemeClr val="accent3"/>
+              <a:schemeClr val="tx1"/>
             </a:solidFill>
             <a:extLst>
               <a:ext uri="{C807C97D-BFC1-408E-A445-0C87EB9F89A2}">
@@ -16529,7 +17187,7 @@
           <a:noFill/>
           <a:ln>
             <a:solidFill>
-              <a:schemeClr val="accent3"/>
+              <a:schemeClr val="tx1"/>
             </a:solidFill>
             <a:extLst>
               <a:ext uri="{C807C97D-BFC1-408E-A445-0C87EB9F89A2}">
@@ -16652,7 +17310,7 @@
           <a:noFill/>
           <a:ln>
             <a:solidFill>
-              <a:schemeClr val="accent3"/>
+              <a:schemeClr val="tx1"/>
             </a:solidFill>
             <a:extLst>
               <a:ext uri="{C807C97D-BFC1-408E-A445-0C87EB9F89A2}">

</xml_diff>

<commit_message>
fix(slides): update final slides
</commit_message>
<xml_diff>
--- a/slides/flsg/7-finetuning-flsg.pptx
+++ b/slides/flsg/7-finetuning-flsg.pptx
@@ -1343,7 +1343,7 @@
           <a:p>
             <a:fld id="{9F0382AD-F4DE-5244-99F0-D1973462CD0B}" type="datetimeFigureOut">
               <a:rPr lang="en-US" smtClean="0"/>
-              <a:t>5/15/26</a:t>
+              <a:t>6/26/26</a:t>
             </a:fld>
             <a:endParaRPr lang="en-US"/>
           </a:p>
@@ -2404,7 +2404,7 @@
           <a:p>
             <a:fld id="{846CE7D5-CF57-46EF-B807-FDD0502418D4}" type="datetimeFigureOut">
               <a:rPr lang="en-GB" smtClean="0"/>
-              <a:t>15/05/2026</a:t>
+              <a:t>26/06/2026</a:t>
             </a:fld>
             <a:endParaRPr lang="en-GB"/>
           </a:p>
@@ -2574,7 +2574,7 @@
           <a:p>
             <a:fld id="{846CE7D5-CF57-46EF-B807-FDD0502418D4}" type="datetimeFigureOut">
               <a:rPr lang="en-GB" smtClean="0"/>
-              <a:t>15/05/2026</a:t>
+              <a:t>26/06/2026</a:t>
             </a:fld>
             <a:endParaRPr lang="en-GB"/>
           </a:p>
@@ -2754,7 +2754,7 @@
           <a:p>
             <a:fld id="{846CE7D5-CF57-46EF-B807-FDD0502418D4}" type="datetimeFigureOut">
               <a:rPr lang="en-GB" smtClean="0"/>
-              <a:t>15/05/2026</a:t>
+              <a:t>26/06/2026</a:t>
             </a:fld>
             <a:endParaRPr lang="en-GB"/>
           </a:p>
@@ -2924,7 +2924,7 @@
           <a:p>
             <a:fld id="{846CE7D5-CF57-46EF-B807-FDD0502418D4}" type="datetimeFigureOut">
               <a:rPr lang="en-GB" smtClean="0"/>
-              <a:t>15/05/2026</a:t>
+              <a:t>26/06/2026</a:t>
             </a:fld>
             <a:endParaRPr lang="en-GB"/>
           </a:p>
@@ -3170,7 +3170,7 @@
           <a:p>
             <a:fld id="{846CE7D5-CF57-46EF-B807-FDD0502418D4}" type="datetimeFigureOut">
               <a:rPr lang="en-GB" smtClean="0"/>
-              <a:t>15/05/2026</a:t>
+              <a:t>26/06/2026</a:t>
             </a:fld>
             <a:endParaRPr lang="en-GB"/>
           </a:p>
@@ -3402,7 +3402,7 @@
           <a:p>
             <a:fld id="{846CE7D5-CF57-46EF-B807-FDD0502418D4}" type="datetimeFigureOut">
               <a:rPr lang="en-GB" smtClean="0"/>
-              <a:t>15/05/2026</a:t>
+              <a:t>26/06/2026</a:t>
             </a:fld>
             <a:endParaRPr lang="en-GB"/>
           </a:p>
@@ -3769,7 +3769,7 @@
           <a:p>
             <a:fld id="{846CE7D5-CF57-46EF-B807-FDD0502418D4}" type="datetimeFigureOut">
               <a:rPr lang="en-GB" smtClean="0"/>
-              <a:t>15/05/2026</a:t>
+              <a:t>26/06/2026</a:t>
             </a:fld>
             <a:endParaRPr lang="en-GB"/>
           </a:p>
@@ -3887,7 +3887,7 @@
           <a:p>
             <a:fld id="{846CE7D5-CF57-46EF-B807-FDD0502418D4}" type="datetimeFigureOut">
               <a:rPr lang="en-GB" smtClean="0"/>
-              <a:t>15/05/2026</a:t>
+              <a:t>26/06/2026</a:t>
             </a:fld>
             <a:endParaRPr lang="en-GB"/>
           </a:p>
@@ -3982,7 +3982,7 @@
           <a:p>
             <a:fld id="{846CE7D5-CF57-46EF-B807-FDD0502418D4}" type="datetimeFigureOut">
               <a:rPr lang="en-GB" smtClean="0"/>
-              <a:t>15/05/2026</a:t>
+              <a:t>26/06/2026</a:t>
             </a:fld>
             <a:endParaRPr lang="en-GB"/>
           </a:p>
@@ -4259,7 +4259,7 @@
           <a:p>
             <a:fld id="{846CE7D5-CF57-46EF-B807-FDD0502418D4}" type="datetimeFigureOut">
               <a:rPr lang="en-GB" smtClean="0"/>
-              <a:t>15/05/2026</a:t>
+              <a:t>26/06/2026</a:t>
             </a:fld>
             <a:endParaRPr lang="en-GB"/>
           </a:p>
@@ -4516,7 +4516,7 @@
           <a:p>
             <a:fld id="{846CE7D5-CF57-46EF-B807-FDD0502418D4}" type="datetimeFigureOut">
               <a:rPr lang="en-GB" smtClean="0"/>
-              <a:t>15/05/2026</a:t>
+              <a:t>26/06/2026</a:t>
             </a:fld>
             <a:endParaRPr lang="en-GB"/>
           </a:p>
@@ -4738,7 +4738,7 @@
           <a:p>
             <a:fld id="{846CE7D5-CF57-46EF-B807-FDD0502418D4}" type="datetimeFigureOut">
               <a:rPr lang="en-GB" smtClean="0"/>
-              <a:t>15/05/2026</a:t>
+              <a:t>26/06/2026</a:t>
             </a:fld>
             <a:endParaRPr lang="en-GB"/>
           </a:p>

</xml_diff>